<commit_message>
feat(presentation): add native OpenXML morph transitions, ambient glow overlays, and interactive animation effects
</commit_message>
<xml_diff>
--- a/Computer_System_Architecture_Cinematic.pptx
+++ b/Computer_System_Architecture_Cinematic.pptx
@@ -5585,7 +5585,7 @@
             <a:avLst/>
           </a:prstGeom>
           <a:solidFill>
-            <a:srgbClr val="FFFFFF"/>
+            <a:srgbClr val="38BDF8"/>
           </a:solidFill>
           <a:ln>
             <a:noFill/>
@@ -5678,6 +5678,9 @@
   <p:clrMapOvr>
     <a:masterClrMapping/>
   </p:clrMapOvr>
+  <p:transition xmlns:p14="http://schemas.microsoft.com/office/powerpoint/2010/main" spd="med" dur="1500">
+    <p14:morph option="byObject"/>
+  </p:transition>
 </p:sld>
 </file>
 
@@ -6025,7 +6028,50 @@
       </p:sp>
       <p:sp>
         <p:nvSpPr>
-          <p:cNvPr id="9" name="TextBox 8"/>
+          <p:cNvPr id="9" name="Rectangle 8"/>
+          <p:cNvSpPr/>
+          <p:nvPr/>
+        </p:nvSpPr>
+        <p:spPr>
+          <a:xfrm>
+            <a:off x="3886200" y="1536192"/>
+            <a:ext cx="137160" cy="18288"/>
+          </a:xfrm>
+          <a:prstGeom prst="rect">
+            <a:avLst/>
+          </a:prstGeom>
+          <a:solidFill>
+            <a:srgbClr val="38BDF8"/>
+          </a:solidFill>
+          <a:ln>
+            <a:noFill/>
+          </a:ln>
+        </p:spPr>
+        <p:style>
+          <a:lnRef idx="1">
+            <a:schemeClr val="accent1"/>
+          </a:lnRef>
+          <a:fillRef idx="3">
+            <a:schemeClr val="accent1"/>
+          </a:fillRef>
+          <a:effectRef idx="2">
+            <a:schemeClr val="accent1"/>
+          </a:effectRef>
+          <a:fontRef idx="minor">
+            <a:schemeClr val="lt1"/>
+          </a:fontRef>
+        </p:style>
+        <p:txBody>
+          <a:bodyPr rtlCol="0" anchor="ctr"/>
+          <a:lstStyle/>
+          <a:p>
+            <a:pPr algn="ctr"/>
+          </a:p>
+        </p:txBody>
+      </p:sp>
+      <p:sp>
+        <p:nvSpPr>
+          <p:cNvPr id="10" name="TextBox 9"/>
           <p:cNvSpPr txBox="1"/>
           <p:nvPr/>
         </p:nvSpPr>
@@ -6061,7 +6107,7 @@
       </p:sp>
       <p:sp>
         <p:nvSpPr>
-          <p:cNvPr id="10" name="Rounded Rectangle 9"/>
+          <p:cNvPr id="11" name="Rounded Rectangle 10"/>
           <p:cNvSpPr/>
           <p:nvPr/>
         </p:nvSpPr>
@@ -6116,7 +6162,7 @@
       </p:sp>
       <p:sp>
         <p:nvSpPr>
-          <p:cNvPr id="11" name="TextBox 10"/>
+          <p:cNvPr id="12" name="TextBox 11"/>
           <p:cNvSpPr txBox="1"/>
           <p:nvPr/>
         </p:nvSpPr>
@@ -6157,7 +6203,7 @@
       </p:sp>
       <p:sp>
         <p:nvSpPr>
-          <p:cNvPr id="12" name="Rounded Rectangle 11"/>
+          <p:cNvPr id="13" name="Rounded Rectangle 12"/>
           <p:cNvSpPr/>
           <p:nvPr/>
         </p:nvSpPr>
@@ -6202,7 +6248,7 @@
       </p:sp>
       <p:sp>
         <p:nvSpPr>
-          <p:cNvPr id="13" name="Rounded Rectangle 12"/>
+          <p:cNvPr id="14" name="Rounded Rectangle 13"/>
           <p:cNvSpPr/>
           <p:nvPr/>
         </p:nvSpPr>
@@ -6245,7 +6291,50 @@
       </p:sp>
       <p:sp>
         <p:nvSpPr>
-          <p:cNvPr id="14" name="TextBox 13"/>
+          <p:cNvPr id="15" name="Rectangle 14"/>
+          <p:cNvSpPr/>
+          <p:nvPr/>
+        </p:nvSpPr>
+        <p:spPr>
+          <a:xfrm>
+            <a:off x="7543800" y="1536192"/>
+            <a:ext cx="137160" cy="18288"/>
+          </a:xfrm>
+          <a:prstGeom prst="rect">
+            <a:avLst/>
+          </a:prstGeom>
+          <a:solidFill>
+            <a:srgbClr val="34D399"/>
+          </a:solidFill>
+          <a:ln>
+            <a:noFill/>
+          </a:ln>
+        </p:spPr>
+        <p:style>
+          <a:lnRef idx="1">
+            <a:schemeClr val="accent1"/>
+          </a:lnRef>
+          <a:fillRef idx="3">
+            <a:schemeClr val="accent1"/>
+          </a:fillRef>
+          <a:effectRef idx="2">
+            <a:schemeClr val="accent1"/>
+          </a:effectRef>
+          <a:fontRef idx="minor">
+            <a:schemeClr val="lt1"/>
+          </a:fontRef>
+        </p:style>
+        <p:txBody>
+          <a:bodyPr rtlCol="0" anchor="ctr"/>
+          <a:lstStyle/>
+          <a:p>
+            <a:pPr algn="ctr"/>
+          </a:p>
+        </p:txBody>
+      </p:sp>
+      <p:sp>
+        <p:nvSpPr>
+          <p:cNvPr id="16" name="TextBox 15"/>
           <p:cNvSpPr txBox="1"/>
           <p:nvPr/>
         </p:nvSpPr>
@@ -6281,7 +6370,7 @@
       </p:sp>
       <p:sp>
         <p:nvSpPr>
-          <p:cNvPr id="15" name="Rounded Rectangle 14"/>
+          <p:cNvPr id="17" name="Rounded Rectangle 16"/>
           <p:cNvSpPr/>
           <p:nvPr/>
         </p:nvSpPr>
@@ -6336,7 +6425,7 @@
       </p:sp>
       <p:sp>
         <p:nvSpPr>
-          <p:cNvPr id="16" name="TextBox 15"/>
+          <p:cNvPr id="18" name="TextBox 17"/>
           <p:cNvSpPr txBox="1"/>
           <p:nvPr/>
         </p:nvSpPr>
@@ -6377,7 +6466,7 @@
       </p:sp>
       <p:sp>
         <p:nvSpPr>
-          <p:cNvPr id="17" name="Rounded Rectangle 16"/>
+          <p:cNvPr id="19" name="Rounded Rectangle 18"/>
           <p:cNvSpPr/>
           <p:nvPr/>
         </p:nvSpPr>
@@ -6422,7 +6511,7 @@
       </p:sp>
       <p:sp>
         <p:nvSpPr>
-          <p:cNvPr id="18" name="Rounded Rectangle 17"/>
+          <p:cNvPr id="20" name="Rounded Rectangle 19"/>
           <p:cNvSpPr/>
           <p:nvPr/>
         </p:nvSpPr>
@@ -6465,7 +6554,50 @@
       </p:sp>
       <p:sp>
         <p:nvSpPr>
-          <p:cNvPr id="19" name="TextBox 18"/>
+          <p:cNvPr id="21" name="Rectangle 20"/>
+          <p:cNvSpPr/>
+          <p:nvPr/>
+        </p:nvSpPr>
+        <p:spPr>
+          <a:xfrm>
+            <a:off x="11201400" y="1536192"/>
+            <a:ext cx="137160" cy="18288"/>
+          </a:xfrm>
+          <a:prstGeom prst="rect">
+            <a:avLst/>
+          </a:prstGeom>
+          <a:solidFill>
+            <a:srgbClr val="818CF8"/>
+          </a:solidFill>
+          <a:ln>
+            <a:noFill/>
+          </a:ln>
+        </p:spPr>
+        <p:style>
+          <a:lnRef idx="1">
+            <a:schemeClr val="accent1"/>
+          </a:lnRef>
+          <a:fillRef idx="3">
+            <a:schemeClr val="accent1"/>
+          </a:fillRef>
+          <a:effectRef idx="2">
+            <a:schemeClr val="accent1"/>
+          </a:effectRef>
+          <a:fontRef idx="minor">
+            <a:schemeClr val="lt1"/>
+          </a:fontRef>
+        </p:style>
+        <p:txBody>
+          <a:bodyPr rtlCol="0" anchor="ctr"/>
+          <a:lstStyle/>
+          <a:p>
+            <a:pPr algn="ctr"/>
+          </a:p>
+        </p:txBody>
+      </p:sp>
+      <p:sp>
+        <p:nvSpPr>
+          <p:cNvPr id="22" name="TextBox 21"/>
           <p:cNvSpPr txBox="1"/>
           <p:nvPr/>
         </p:nvSpPr>
@@ -6501,7 +6633,7 @@
       </p:sp>
       <p:sp>
         <p:nvSpPr>
-          <p:cNvPr id="20" name="Rounded Rectangle 19"/>
+          <p:cNvPr id="23" name="Rounded Rectangle 22"/>
           <p:cNvSpPr/>
           <p:nvPr/>
         </p:nvSpPr>
@@ -6556,7 +6688,7 @@
       </p:sp>
       <p:sp>
         <p:nvSpPr>
-          <p:cNvPr id="21" name="TextBox 20"/>
+          <p:cNvPr id="24" name="TextBox 23"/>
           <p:cNvSpPr txBox="1"/>
           <p:nvPr/>
         </p:nvSpPr>
@@ -6597,7 +6729,7 @@
       </p:sp>
       <p:sp>
         <p:nvSpPr>
-          <p:cNvPr id="22" name="Rounded Rectangle 21"/>
+          <p:cNvPr id="25" name="Rounded Rectangle 24"/>
           <p:cNvSpPr/>
           <p:nvPr/>
         </p:nvSpPr>
@@ -6642,7 +6774,50 @@
       </p:sp>
       <p:sp>
         <p:nvSpPr>
-          <p:cNvPr id="23" name="TextBox 22"/>
+          <p:cNvPr id="26" name="Rectangle 25"/>
+          <p:cNvSpPr/>
+          <p:nvPr/>
+        </p:nvSpPr>
+        <p:spPr>
+          <a:xfrm>
+            <a:off x="11231575" y="5879592"/>
+            <a:ext cx="137160" cy="18288"/>
+          </a:xfrm>
+          <a:prstGeom prst="rect">
+            <a:avLst/>
+          </a:prstGeom>
+          <a:solidFill>
+            <a:srgbClr val="2E364A"/>
+          </a:solidFill>
+          <a:ln>
+            <a:noFill/>
+          </a:ln>
+        </p:spPr>
+        <p:style>
+          <a:lnRef idx="1">
+            <a:schemeClr val="accent1"/>
+          </a:lnRef>
+          <a:fillRef idx="3">
+            <a:schemeClr val="accent1"/>
+          </a:fillRef>
+          <a:effectRef idx="2">
+            <a:schemeClr val="accent1"/>
+          </a:effectRef>
+          <a:fontRef idx="minor">
+            <a:schemeClr val="lt1"/>
+          </a:fontRef>
+        </p:style>
+        <p:txBody>
+          <a:bodyPr rtlCol="0" anchor="ctr"/>
+          <a:lstStyle/>
+          <a:p>
+            <a:pPr algn="ctr"/>
+          </a:p>
+        </p:txBody>
+      </p:sp>
+      <p:sp>
+        <p:nvSpPr>
+          <p:cNvPr id="27" name="TextBox 26"/>
           <p:cNvSpPr txBox="1"/>
           <p:nvPr/>
         </p:nvSpPr>
@@ -6688,6 +6863,9 @@
   <p:clrMapOvr>
     <a:masterClrMapping/>
   </p:clrMapOvr>
+  <p:transition xmlns:p14="http://schemas.microsoft.com/office/powerpoint/2010/main" spd="med" dur="1500">
+    <p14:morph option="byObject"/>
+  </p:transition>
 </p:sld>
 </file>
 
@@ -7035,7 +7213,50 @@
       </p:sp>
       <p:sp>
         <p:nvSpPr>
-          <p:cNvPr id="9" name="TextBox 8"/>
+          <p:cNvPr id="9" name="Rectangle 8"/>
+          <p:cNvSpPr/>
+          <p:nvPr/>
+        </p:nvSpPr>
+        <p:spPr>
+          <a:xfrm>
+            <a:off x="3886200" y="1536192"/>
+            <a:ext cx="137160" cy="18288"/>
+          </a:xfrm>
+          <a:prstGeom prst="rect">
+            <a:avLst/>
+          </a:prstGeom>
+          <a:solidFill>
+            <a:srgbClr val="38BDF8"/>
+          </a:solidFill>
+          <a:ln>
+            <a:noFill/>
+          </a:ln>
+        </p:spPr>
+        <p:style>
+          <a:lnRef idx="1">
+            <a:schemeClr val="accent1"/>
+          </a:lnRef>
+          <a:fillRef idx="3">
+            <a:schemeClr val="accent1"/>
+          </a:fillRef>
+          <a:effectRef idx="2">
+            <a:schemeClr val="accent1"/>
+          </a:effectRef>
+          <a:fontRef idx="minor">
+            <a:schemeClr val="lt1"/>
+          </a:fontRef>
+        </p:style>
+        <p:txBody>
+          <a:bodyPr rtlCol="0" anchor="ctr"/>
+          <a:lstStyle/>
+          <a:p>
+            <a:pPr algn="ctr"/>
+          </a:p>
+        </p:txBody>
+      </p:sp>
+      <p:sp>
+        <p:nvSpPr>
+          <p:cNvPr id="10" name="TextBox 9"/>
           <p:cNvSpPr txBox="1"/>
           <p:nvPr/>
         </p:nvSpPr>
@@ -7071,7 +7292,7 @@
       </p:sp>
       <p:sp>
         <p:nvSpPr>
-          <p:cNvPr id="10" name="TextBox 9"/>
+          <p:cNvPr id="11" name="TextBox 10"/>
           <p:cNvSpPr txBox="1"/>
           <p:nvPr/>
         </p:nvSpPr>
@@ -7166,7 +7387,7 @@
       </p:sp>
       <p:sp>
         <p:nvSpPr>
-          <p:cNvPr id="11" name="Rounded Rectangle 10"/>
+          <p:cNvPr id="12" name="Rounded Rectangle 11"/>
           <p:cNvSpPr/>
           <p:nvPr/>
         </p:nvSpPr>
@@ -7211,7 +7432,7 @@
       </p:sp>
       <p:sp>
         <p:nvSpPr>
-          <p:cNvPr id="12" name="Rounded Rectangle 11"/>
+          <p:cNvPr id="13" name="Rounded Rectangle 12"/>
           <p:cNvSpPr/>
           <p:nvPr/>
         </p:nvSpPr>
@@ -7254,7 +7475,50 @@
       </p:sp>
       <p:sp>
         <p:nvSpPr>
-          <p:cNvPr id="13" name="TextBox 12"/>
+          <p:cNvPr id="14" name="Rectangle 13"/>
+          <p:cNvSpPr/>
+          <p:nvPr/>
+        </p:nvSpPr>
+        <p:spPr>
+          <a:xfrm>
+            <a:off x="7543800" y="1536192"/>
+            <a:ext cx="137160" cy="18288"/>
+          </a:xfrm>
+          <a:prstGeom prst="rect">
+            <a:avLst/>
+          </a:prstGeom>
+          <a:solidFill>
+            <a:srgbClr val="818CF8"/>
+          </a:solidFill>
+          <a:ln>
+            <a:noFill/>
+          </a:ln>
+        </p:spPr>
+        <p:style>
+          <a:lnRef idx="1">
+            <a:schemeClr val="accent1"/>
+          </a:lnRef>
+          <a:fillRef idx="3">
+            <a:schemeClr val="accent1"/>
+          </a:fillRef>
+          <a:effectRef idx="2">
+            <a:schemeClr val="accent1"/>
+          </a:effectRef>
+          <a:fontRef idx="minor">
+            <a:schemeClr val="lt1"/>
+          </a:fontRef>
+        </p:style>
+        <p:txBody>
+          <a:bodyPr rtlCol="0" anchor="ctr"/>
+          <a:lstStyle/>
+          <a:p>
+            <a:pPr algn="ctr"/>
+          </a:p>
+        </p:txBody>
+      </p:sp>
+      <p:sp>
+        <p:nvSpPr>
+          <p:cNvPr id="15" name="TextBox 14"/>
           <p:cNvSpPr txBox="1"/>
           <p:nvPr/>
         </p:nvSpPr>
@@ -7290,7 +7554,7 @@
       </p:sp>
       <p:sp>
         <p:nvSpPr>
-          <p:cNvPr id="14" name="TextBox 13"/>
+          <p:cNvPr id="16" name="TextBox 15"/>
           <p:cNvSpPr txBox="1"/>
           <p:nvPr/>
         </p:nvSpPr>
@@ -7385,7 +7649,7 @@
       </p:sp>
       <p:sp>
         <p:nvSpPr>
-          <p:cNvPr id="15" name="Rounded Rectangle 14"/>
+          <p:cNvPr id="17" name="Rounded Rectangle 16"/>
           <p:cNvSpPr/>
           <p:nvPr/>
         </p:nvSpPr>
@@ -7430,7 +7694,7 @@
       </p:sp>
       <p:sp>
         <p:nvSpPr>
-          <p:cNvPr id="16" name="Rounded Rectangle 15"/>
+          <p:cNvPr id="18" name="Rounded Rectangle 17"/>
           <p:cNvSpPr/>
           <p:nvPr/>
         </p:nvSpPr>
@@ -7473,7 +7737,50 @@
       </p:sp>
       <p:sp>
         <p:nvSpPr>
-          <p:cNvPr id="17" name="TextBox 16"/>
+          <p:cNvPr id="19" name="Rectangle 18"/>
+          <p:cNvSpPr/>
+          <p:nvPr/>
+        </p:nvSpPr>
+        <p:spPr>
+          <a:xfrm>
+            <a:off x="11201400" y="1536192"/>
+            <a:ext cx="137160" cy="18288"/>
+          </a:xfrm>
+          <a:prstGeom prst="rect">
+            <a:avLst/>
+          </a:prstGeom>
+          <a:solidFill>
+            <a:srgbClr val="34D399"/>
+          </a:solidFill>
+          <a:ln>
+            <a:noFill/>
+          </a:ln>
+        </p:spPr>
+        <p:style>
+          <a:lnRef idx="1">
+            <a:schemeClr val="accent1"/>
+          </a:lnRef>
+          <a:fillRef idx="3">
+            <a:schemeClr val="accent1"/>
+          </a:fillRef>
+          <a:effectRef idx="2">
+            <a:schemeClr val="accent1"/>
+          </a:effectRef>
+          <a:fontRef idx="minor">
+            <a:schemeClr val="lt1"/>
+          </a:fontRef>
+        </p:style>
+        <p:txBody>
+          <a:bodyPr rtlCol="0" anchor="ctr"/>
+          <a:lstStyle/>
+          <a:p>
+            <a:pPr algn="ctr"/>
+          </a:p>
+        </p:txBody>
+      </p:sp>
+      <p:sp>
+        <p:nvSpPr>
+          <p:cNvPr id="20" name="TextBox 19"/>
           <p:cNvSpPr txBox="1"/>
           <p:nvPr/>
         </p:nvSpPr>
@@ -7509,7 +7816,7 @@
       </p:sp>
       <p:sp>
         <p:nvSpPr>
-          <p:cNvPr id="18" name="TextBox 17"/>
+          <p:cNvPr id="21" name="TextBox 20"/>
           <p:cNvSpPr txBox="1"/>
           <p:nvPr/>
         </p:nvSpPr>
@@ -7604,7 +7911,7 @@
       </p:sp>
       <p:sp>
         <p:nvSpPr>
-          <p:cNvPr id="19" name="Rounded Rectangle 18"/>
+          <p:cNvPr id="22" name="Rounded Rectangle 21"/>
           <p:cNvSpPr/>
           <p:nvPr/>
         </p:nvSpPr>
@@ -7649,7 +7956,50 @@
       </p:sp>
       <p:sp>
         <p:nvSpPr>
-          <p:cNvPr id="20" name="TextBox 19"/>
+          <p:cNvPr id="23" name="Rectangle 22"/>
+          <p:cNvSpPr/>
+          <p:nvPr/>
+        </p:nvSpPr>
+        <p:spPr>
+          <a:xfrm>
+            <a:off x="11231575" y="5879592"/>
+            <a:ext cx="137160" cy="18288"/>
+          </a:xfrm>
+          <a:prstGeom prst="rect">
+            <a:avLst/>
+          </a:prstGeom>
+          <a:solidFill>
+            <a:srgbClr val="2E364A"/>
+          </a:solidFill>
+          <a:ln>
+            <a:noFill/>
+          </a:ln>
+        </p:spPr>
+        <p:style>
+          <a:lnRef idx="1">
+            <a:schemeClr val="accent1"/>
+          </a:lnRef>
+          <a:fillRef idx="3">
+            <a:schemeClr val="accent1"/>
+          </a:fillRef>
+          <a:effectRef idx="2">
+            <a:schemeClr val="accent1"/>
+          </a:effectRef>
+          <a:fontRef idx="minor">
+            <a:schemeClr val="lt1"/>
+          </a:fontRef>
+        </p:style>
+        <p:txBody>
+          <a:bodyPr rtlCol="0" anchor="ctr"/>
+          <a:lstStyle/>
+          <a:p>
+            <a:pPr algn="ctr"/>
+          </a:p>
+        </p:txBody>
+      </p:sp>
+      <p:sp>
+        <p:nvSpPr>
+          <p:cNvPr id="24" name="TextBox 23"/>
           <p:cNvSpPr txBox="1"/>
           <p:nvPr/>
         </p:nvSpPr>
@@ -7695,6 +8045,9 @@
   <p:clrMapOvr>
     <a:masterClrMapping/>
   </p:clrMapOvr>
+  <p:transition xmlns:p14="http://schemas.microsoft.com/office/powerpoint/2010/main" spd="med" dur="1500">
+    <p14:morph option="byObject"/>
+  </p:transition>
 </p:sld>
 </file>
 
@@ -8042,7 +8395,50 @@
       </p:sp>
       <p:sp>
         <p:nvSpPr>
-          <p:cNvPr id="9" name="TextBox 8"/>
+          <p:cNvPr id="9" name="Rectangle 8"/>
+          <p:cNvSpPr/>
+          <p:nvPr/>
+        </p:nvSpPr>
+        <p:spPr>
+          <a:xfrm>
+            <a:off x="11231575" y="1536192"/>
+            <a:ext cx="137160" cy="18288"/>
+          </a:xfrm>
+          <a:prstGeom prst="rect">
+            <a:avLst/>
+          </a:prstGeom>
+          <a:solidFill>
+            <a:srgbClr val="38BDF8"/>
+          </a:solidFill>
+          <a:ln>
+            <a:noFill/>
+          </a:ln>
+        </p:spPr>
+        <p:style>
+          <a:lnRef idx="1">
+            <a:schemeClr val="accent1"/>
+          </a:lnRef>
+          <a:fillRef idx="3">
+            <a:schemeClr val="accent1"/>
+          </a:fillRef>
+          <a:effectRef idx="2">
+            <a:schemeClr val="accent1"/>
+          </a:effectRef>
+          <a:fontRef idx="minor">
+            <a:schemeClr val="lt1"/>
+          </a:fontRef>
+        </p:style>
+        <p:txBody>
+          <a:bodyPr rtlCol="0" anchor="ctr"/>
+          <a:lstStyle/>
+          <a:p>
+            <a:pPr algn="ctr"/>
+          </a:p>
+        </p:txBody>
+      </p:sp>
+      <p:sp>
+        <p:nvSpPr>
+          <p:cNvPr id="10" name="TextBox 9"/>
           <p:cNvSpPr txBox="1"/>
           <p:nvPr/>
         </p:nvSpPr>
@@ -8078,7 +8474,7 @@
       </p:sp>
       <p:graphicFrame>
         <p:nvGraphicFramePr>
-          <p:cNvPr id="10" name="Table 9"/>
+          <p:cNvPr id="11" name="Table 10"/>
           <p:cNvGraphicFramePr>
             <a:graphicFrameLocks noGrp="1"/>
           </p:cNvGraphicFramePr>
@@ -8401,7 +8797,7 @@
       </p:graphicFrame>
       <p:sp>
         <p:nvSpPr>
-          <p:cNvPr id="11" name="Rounded Rectangle 10"/>
+          <p:cNvPr id="12" name="Rounded Rectangle 11"/>
           <p:cNvSpPr/>
           <p:nvPr/>
         </p:nvSpPr>
@@ -8446,7 +8842,7 @@
       </p:sp>
       <p:sp>
         <p:nvSpPr>
-          <p:cNvPr id="12" name="Rounded Rectangle 11"/>
+          <p:cNvPr id="13" name="Rounded Rectangle 12"/>
           <p:cNvSpPr/>
           <p:nvPr/>
         </p:nvSpPr>
@@ -8489,7 +8885,50 @@
       </p:sp>
       <p:sp>
         <p:nvSpPr>
-          <p:cNvPr id="13" name="TextBox 12"/>
+          <p:cNvPr id="14" name="Rectangle 13"/>
+          <p:cNvSpPr/>
+          <p:nvPr/>
+        </p:nvSpPr>
+        <p:spPr>
+          <a:xfrm>
+            <a:off x="5715000" y="4187952"/>
+            <a:ext cx="137160" cy="18288"/>
+          </a:xfrm>
+          <a:prstGeom prst="rect">
+            <a:avLst/>
+          </a:prstGeom>
+          <a:solidFill>
+            <a:srgbClr val="F59E0B"/>
+          </a:solidFill>
+          <a:ln>
+            <a:noFill/>
+          </a:ln>
+        </p:spPr>
+        <p:style>
+          <a:lnRef idx="1">
+            <a:schemeClr val="accent1"/>
+          </a:lnRef>
+          <a:fillRef idx="3">
+            <a:schemeClr val="accent1"/>
+          </a:fillRef>
+          <a:effectRef idx="2">
+            <a:schemeClr val="accent1"/>
+          </a:effectRef>
+          <a:fontRef idx="minor">
+            <a:schemeClr val="lt1"/>
+          </a:fontRef>
+        </p:style>
+        <p:txBody>
+          <a:bodyPr rtlCol="0" anchor="ctr"/>
+          <a:lstStyle/>
+          <a:p>
+            <a:pPr algn="ctr"/>
+          </a:p>
+        </p:txBody>
+      </p:sp>
+      <p:sp>
+        <p:nvSpPr>
+          <p:cNvPr id="15" name="TextBox 14"/>
           <p:cNvSpPr txBox="1"/>
           <p:nvPr/>
         </p:nvSpPr>
@@ -8525,7 +8964,7 @@
       </p:sp>
       <p:sp>
         <p:nvSpPr>
-          <p:cNvPr id="14" name="TextBox 13"/>
+          <p:cNvPr id="16" name="TextBox 15"/>
           <p:cNvSpPr txBox="1"/>
           <p:nvPr/>
         </p:nvSpPr>
@@ -8595,7 +9034,7 @@
       </p:sp>
       <p:sp>
         <p:nvSpPr>
-          <p:cNvPr id="15" name="Rounded Rectangle 14"/>
+          <p:cNvPr id="17" name="Rounded Rectangle 16"/>
           <p:cNvSpPr/>
           <p:nvPr/>
         </p:nvSpPr>
@@ -8640,7 +9079,7 @@
       </p:sp>
       <p:sp>
         <p:nvSpPr>
-          <p:cNvPr id="16" name="Rounded Rectangle 15"/>
+          <p:cNvPr id="18" name="Rounded Rectangle 17"/>
           <p:cNvSpPr/>
           <p:nvPr/>
         </p:nvSpPr>
@@ -8683,7 +9122,50 @@
       </p:sp>
       <p:sp>
         <p:nvSpPr>
-          <p:cNvPr id="17" name="TextBox 16"/>
+          <p:cNvPr id="19" name="Rectangle 18"/>
+          <p:cNvSpPr/>
+          <p:nvPr/>
+        </p:nvSpPr>
+        <p:spPr>
+          <a:xfrm>
+            <a:off x="11201400" y="4187952"/>
+            <a:ext cx="137160" cy="18288"/>
+          </a:xfrm>
+          <a:prstGeom prst="rect">
+            <a:avLst/>
+          </a:prstGeom>
+          <a:solidFill>
+            <a:srgbClr val="34D399"/>
+          </a:solidFill>
+          <a:ln>
+            <a:noFill/>
+          </a:ln>
+        </p:spPr>
+        <p:style>
+          <a:lnRef idx="1">
+            <a:schemeClr val="accent1"/>
+          </a:lnRef>
+          <a:fillRef idx="3">
+            <a:schemeClr val="accent1"/>
+          </a:fillRef>
+          <a:effectRef idx="2">
+            <a:schemeClr val="accent1"/>
+          </a:effectRef>
+          <a:fontRef idx="minor">
+            <a:schemeClr val="lt1"/>
+          </a:fontRef>
+        </p:style>
+        <p:txBody>
+          <a:bodyPr rtlCol="0" anchor="ctr"/>
+          <a:lstStyle/>
+          <a:p>
+            <a:pPr algn="ctr"/>
+          </a:p>
+        </p:txBody>
+      </p:sp>
+      <p:sp>
+        <p:nvSpPr>
+          <p:cNvPr id="20" name="TextBox 19"/>
           <p:cNvSpPr txBox="1"/>
           <p:nvPr/>
         </p:nvSpPr>
@@ -8719,7 +9201,7 @@
       </p:sp>
       <p:sp>
         <p:nvSpPr>
-          <p:cNvPr id="18" name="TextBox 17"/>
+          <p:cNvPr id="21" name="TextBox 20"/>
           <p:cNvSpPr txBox="1"/>
           <p:nvPr/>
         </p:nvSpPr>
@@ -8792,6 +9274,9 @@
   <p:clrMapOvr>
     <a:masterClrMapping/>
   </p:clrMapOvr>
+  <p:transition xmlns:p14="http://schemas.microsoft.com/office/powerpoint/2010/main" spd="med" dur="1500">
+    <p14:morph option="byObject"/>
+  </p:transition>
 </p:sld>
 </file>
 
@@ -9139,7 +9624,50 @@
       </p:sp>
       <p:sp>
         <p:nvSpPr>
-          <p:cNvPr id="9" name="TextBox 8"/>
+          <p:cNvPr id="9" name="Rectangle 8"/>
+          <p:cNvSpPr/>
+          <p:nvPr/>
+        </p:nvSpPr>
+        <p:spPr>
+          <a:xfrm>
+            <a:off x="5715000" y="1536192"/>
+            <a:ext cx="137160" cy="18288"/>
+          </a:xfrm>
+          <a:prstGeom prst="rect">
+            <a:avLst/>
+          </a:prstGeom>
+          <a:solidFill>
+            <a:srgbClr val="38BDF8"/>
+          </a:solidFill>
+          <a:ln>
+            <a:noFill/>
+          </a:ln>
+        </p:spPr>
+        <p:style>
+          <a:lnRef idx="1">
+            <a:schemeClr val="accent1"/>
+          </a:lnRef>
+          <a:fillRef idx="3">
+            <a:schemeClr val="accent1"/>
+          </a:fillRef>
+          <a:effectRef idx="2">
+            <a:schemeClr val="accent1"/>
+          </a:effectRef>
+          <a:fontRef idx="minor">
+            <a:schemeClr val="lt1"/>
+          </a:fontRef>
+        </p:style>
+        <p:txBody>
+          <a:bodyPr rtlCol="0" anchor="ctr"/>
+          <a:lstStyle/>
+          <a:p>
+            <a:pPr algn="ctr"/>
+          </a:p>
+        </p:txBody>
+      </p:sp>
+      <p:sp>
+        <p:nvSpPr>
+          <p:cNvPr id="10" name="TextBox 9"/>
           <p:cNvSpPr txBox="1"/>
           <p:nvPr/>
         </p:nvSpPr>
@@ -9175,7 +9703,7 @@
       </p:sp>
       <p:sp>
         <p:nvSpPr>
-          <p:cNvPr id="10" name="TextBox 9"/>
+          <p:cNvPr id="11" name="TextBox 10"/>
           <p:cNvSpPr txBox="1"/>
           <p:nvPr/>
         </p:nvSpPr>
@@ -9325,7 +9853,7 @@
       </p:sp>
       <p:sp>
         <p:nvSpPr>
-          <p:cNvPr id="11" name="Rounded Rectangle 10"/>
+          <p:cNvPr id="12" name="Rounded Rectangle 11"/>
           <p:cNvSpPr/>
           <p:nvPr/>
         </p:nvSpPr>
@@ -9370,7 +9898,7 @@
       </p:sp>
       <p:sp>
         <p:nvSpPr>
-          <p:cNvPr id="12" name="Rounded Rectangle 11"/>
+          <p:cNvPr id="13" name="Rounded Rectangle 12"/>
           <p:cNvSpPr/>
           <p:nvPr/>
         </p:nvSpPr>
@@ -9413,7 +9941,50 @@
       </p:sp>
       <p:sp>
         <p:nvSpPr>
-          <p:cNvPr id="13" name="TextBox 12"/>
+          <p:cNvPr id="14" name="Rectangle 13"/>
+          <p:cNvSpPr/>
+          <p:nvPr/>
+        </p:nvSpPr>
+        <p:spPr>
+          <a:xfrm>
+            <a:off x="11201400" y="1536192"/>
+            <a:ext cx="137160" cy="18288"/>
+          </a:xfrm>
+          <a:prstGeom prst="rect">
+            <a:avLst/>
+          </a:prstGeom>
+          <a:solidFill>
+            <a:srgbClr val="818CF8"/>
+          </a:solidFill>
+          <a:ln>
+            <a:noFill/>
+          </a:ln>
+        </p:spPr>
+        <p:style>
+          <a:lnRef idx="1">
+            <a:schemeClr val="accent1"/>
+          </a:lnRef>
+          <a:fillRef idx="3">
+            <a:schemeClr val="accent1"/>
+          </a:fillRef>
+          <a:effectRef idx="2">
+            <a:schemeClr val="accent1"/>
+          </a:effectRef>
+          <a:fontRef idx="minor">
+            <a:schemeClr val="lt1"/>
+          </a:fontRef>
+        </p:style>
+        <p:txBody>
+          <a:bodyPr rtlCol="0" anchor="ctr"/>
+          <a:lstStyle/>
+          <a:p>
+            <a:pPr algn="ctr"/>
+          </a:p>
+        </p:txBody>
+      </p:sp>
+      <p:sp>
+        <p:nvSpPr>
+          <p:cNvPr id="15" name="TextBox 14"/>
           <p:cNvSpPr txBox="1"/>
           <p:nvPr/>
         </p:nvSpPr>
@@ -9449,7 +10020,7 @@
       </p:sp>
       <p:sp>
         <p:nvSpPr>
-          <p:cNvPr id="14" name="TextBox 13"/>
+          <p:cNvPr id="16" name="TextBox 15"/>
           <p:cNvSpPr txBox="1"/>
           <p:nvPr/>
         </p:nvSpPr>
@@ -9576,6 +10147,9 @@
   <p:clrMapOvr>
     <a:masterClrMapping/>
   </p:clrMapOvr>
+  <p:transition xmlns:p14="http://schemas.microsoft.com/office/powerpoint/2010/main" spd="med" dur="1500">
+    <p14:morph option="byObject"/>
+  </p:transition>
 </p:sld>
 </file>
 
@@ -9923,7 +10497,50 @@
       </p:sp>
       <p:sp>
         <p:nvSpPr>
-          <p:cNvPr id="9" name="TextBox 8"/>
+          <p:cNvPr id="9" name="Rectangle 8"/>
+          <p:cNvSpPr/>
+          <p:nvPr/>
+        </p:nvSpPr>
+        <p:spPr>
+          <a:xfrm>
+            <a:off x="5715000" y="1536192"/>
+            <a:ext cx="137160" cy="18288"/>
+          </a:xfrm>
+          <a:prstGeom prst="rect">
+            <a:avLst/>
+          </a:prstGeom>
+          <a:solidFill>
+            <a:srgbClr val="38BDF8"/>
+          </a:solidFill>
+          <a:ln>
+            <a:noFill/>
+          </a:ln>
+        </p:spPr>
+        <p:style>
+          <a:lnRef idx="1">
+            <a:schemeClr val="accent1"/>
+          </a:lnRef>
+          <a:fillRef idx="3">
+            <a:schemeClr val="accent1"/>
+          </a:fillRef>
+          <a:effectRef idx="2">
+            <a:schemeClr val="accent1"/>
+          </a:effectRef>
+          <a:fontRef idx="minor">
+            <a:schemeClr val="lt1"/>
+          </a:fontRef>
+        </p:style>
+        <p:txBody>
+          <a:bodyPr rtlCol="0" anchor="ctr"/>
+          <a:lstStyle/>
+          <a:p>
+            <a:pPr algn="ctr"/>
+          </a:p>
+        </p:txBody>
+      </p:sp>
+      <p:sp>
+        <p:nvSpPr>
+          <p:cNvPr id="10" name="TextBox 9"/>
           <p:cNvSpPr txBox="1"/>
           <p:nvPr/>
         </p:nvSpPr>
@@ -9959,7 +10576,7 @@
       </p:sp>
       <p:sp>
         <p:nvSpPr>
-          <p:cNvPr id="10" name="TextBox 9"/>
+          <p:cNvPr id="11" name="TextBox 10"/>
           <p:cNvSpPr txBox="1"/>
           <p:nvPr/>
         </p:nvSpPr>
@@ -9995,7 +10612,7 @@
       </p:sp>
       <p:sp>
         <p:nvSpPr>
-          <p:cNvPr id="11" name="Rounded Rectangle 10"/>
+          <p:cNvPr id="12" name="Rounded Rectangle 11"/>
           <p:cNvSpPr/>
           <p:nvPr/>
         </p:nvSpPr>
@@ -10040,7 +10657,7 @@
       </p:sp>
       <p:sp>
         <p:nvSpPr>
-          <p:cNvPr id="12" name="Rounded Rectangle 11"/>
+          <p:cNvPr id="13" name="Rounded Rectangle 12"/>
           <p:cNvSpPr/>
           <p:nvPr/>
         </p:nvSpPr>
@@ -10083,7 +10700,50 @@
       </p:sp>
       <p:sp>
         <p:nvSpPr>
-          <p:cNvPr id="13" name="TextBox 12"/>
+          <p:cNvPr id="14" name="Rectangle 13"/>
+          <p:cNvSpPr/>
+          <p:nvPr/>
+        </p:nvSpPr>
+        <p:spPr>
+          <a:xfrm>
+            <a:off x="11201400" y="1536192"/>
+            <a:ext cx="137160" cy="18288"/>
+          </a:xfrm>
+          <a:prstGeom prst="rect">
+            <a:avLst/>
+          </a:prstGeom>
+          <a:solidFill>
+            <a:srgbClr val="818CF8"/>
+          </a:solidFill>
+          <a:ln>
+            <a:noFill/>
+          </a:ln>
+        </p:spPr>
+        <p:style>
+          <a:lnRef idx="1">
+            <a:schemeClr val="accent1"/>
+          </a:lnRef>
+          <a:fillRef idx="3">
+            <a:schemeClr val="accent1"/>
+          </a:fillRef>
+          <a:effectRef idx="2">
+            <a:schemeClr val="accent1"/>
+          </a:effectRef>
+          <a:fontRef idx="minor">
+            <a:schemeClr val="lt1"/>
+          </a:fontRef>
+        </p:style>
+        <p:txBody>
+          <a:bodyPr rtlCol="0" anchor="ctr"/>
+          <a:lstStyle/>
+          <a:p>
+            <a:pPr algn="ctr"/>
+          </a:p>
+        </p:txBody>
+      </p:sp>
+      <p:sp>
+        <p:nvSpPr>
+          <p:cNvPr id="15" name="TextBox 14"/>
           <p:cNvSpPr txBox="1"/>
           <p:nvPr/>
         </p:nvSpPr>
@@ -10119,7 +10779,7 @@
       </p:sp>
       <p:sp>
         <p:nvSpPr>
-          <p:cNvPr id="14" name="TextBox 13"/>
+          <p:cNvPr id="16" name="TextBox 15"/>
           <p:cNvSpPr txBox="1"/>
           <p:nvPr/>
         </p:nvSpPr>
@@ -10155,7 +10815,7 @@
       </p:sp>
       <p:sp>
         <p:nvSpPr>
-          <p:cNvPr id="15" name="Rounded Rectangle 14"/>
+          <p:cNvPr id="17" name="Rounded Rectangle 16"/>
           <p:cNvSpPr/>
           <p:nvPr/>
         </p:nvSpPr>
@@ -10200,7 +10860,7 @@
       </p:sp>
       <p:sp>
         <p:nvSpPr>
-          <p:cNvPr id="16" name="Rounded Rectangle 15"/>
+          <p:cNvPr id="18" name="Rounded Rectangle 17"/>
           <p:cNvSpPr/>
           <p:nvPr/>
         </p:nvSpPr>
@@ -10243,7 +10903,50 @@
       </p:sp>
       <p:sp>
         <p:nvSpPr>
-          <p:cNvPr id="17" name="TextBox 16"/>
+          <p:cNvPr id="19" name="Rectangle 18"/>
+          <p:cNvSpPr/>
+          <p:nvPr/>
+        </p:nvSpPr>
+        <p:spPr>
+          <a:xfrm>
+            <a:off x="5715000" y="3913632"/>
+            <a:ext cx="137160" cy="18288"/>
+          </a:xfrm>
+          <a:prstGeom prst="rect">
+            <a:avLst/>
+          </a:prstGeom>
+          <a:solidFill>
+            <a:srgbClr val="34D399"/>
+          </a:solidFill>
+          <a:ln>
+            <a:noFill/>
+          </a:ln>
+        </p:spPr>
+        <p:style>
+          <a:lnRef idx="1">
+            <a:schemeClr val="accent1"/>
+          </a:lnRef>
+          <a:fillRef idx="3">
+            <a:schemeClr val="accent1"/>
+          </a:fillRef>
+          <a:effectRef idx="2">
+            <a:schemeClr val="accent1"/>
+          </a:effectRef>
+          <a:fontRef idx="minor">
+            <a:schemeClr val="lt1"/>
+          </a:fontRef>
+        </p:style>
+        <p:txBody>
+          <a:bodyPr rtlCol="0" anchor="ctr"/>
+          <a:lstStyle/>
+          <a:p>
+            <a:pPr algn="ctr"/>
+          </a:p>
+        </p:txBody>
+      </p:sp>
+      <p:sp>
+        <p:nvSpPr>
+          <p:cNvPr id="20" name="TextBox 19"/>
           <p:cNvSpPr txBox="1"/>
           <p:nvPr/>
         </p:nvSpPr>
@@ -10279,7 +10982,7 @@
       </p:sp>
       <p:sp>
         <p:nvSpPr>
-          <p:cNvPr id="18" name="TextBox 17"/>
+          <p:cNvPr id="21" name="TextBox 20"/>
           <p:cNvSpPr txBox="1"/>
           <p:nvPr/>
         </p:nvSpPr>
@@ -10315,7 +11018,7 @@
       </p:sp>
       <p:sp>
         <p:nvSpPr>
-          <p:cNvPr id="19" name="Rounded Rectangle 18"/>
+          <p:cNvPr id="22" name="Rounded Rectangle 21"/>
           <p:cNvSpPr/>
           <p:nvPr/>
         </p:nvSpPr>
@@ -10360,7 +11063,7 @@
       </p:sp>
       <p:sp>
         <p:nvSpPr>
-          <p:cNvPr id="20" name="Rounded Rectangle 19"/>
+          <p:cNvPr id="23" name="Rounded Rectangle 22"/>
           <p:cNvSpPr/>
           <p:nvPr/>
         </p:nvSpPr>
@@ -10403,7 +11106,50 @@
       </p:sp>
       <p:sp>
         <p:nvSpPr>
-          <p:cNvPr id="21" name="TextBox 20"/>
+          <p:cNvPr id="24" name="Rectangle 23"/>
+          <p:cNvSpPr/>
+          <p:nvPr/>
+        </p:nvSpPr>
+        <p:spPr>
+          <a:xfrm>
+            <a:off x="11201400" y="3913632"/>
+            <a:ext cx="137160" cy="18288"/>
+          </a:xfrm>
+          <a:prstGeom prst="rect">
+            <a:avLst/>
+          </a:prstGeom>
+          <a:solidFill>
+            <a:srgbClr val="F59E0B"/>
+          </a:solidFill>
+          <a:ln>
+            <a:noFill/>
+          </a:ln>
+        </p:spPr>
+        <p:style>
+          <a:lnRef idx="1">
+            <a:schemeClr val="accent1"/>
+          </a:lnRef>
+          <a:fillRef idx="3">
+            <a:schemeClr val="accent1"/>
+          </a:fillRef>
+          <a:effectRef idx="2">
+            <a:schemeClr val="accent1"/>
+          </a:effectRef>
+          <a:fontRef idx="minor">
+            <a:schemeClr val="lt1"/>
+          </a:fontRef>
+        </p:style>
+        <p:txBody>
+          <a:bodyPr rtlCol="0" anchor="ctr"/>
+          <a:lstStyle/>
+          <a:p>
+            <a:pPr algn="ctr"/>
+          </a:p>
+        </p:txBody>
+      </p:sp>
+      <p:sp>
+        <p:nvSpPr>
+          <p:cNvPr id="25" name="TextBox 24"/>
           <p:cNvSpPr txBox="1"/>
           <p:nvPr/>
         </p:nvSpPr>
@@ -10439,7 +11185,7 @@
       </p:sp>
       <p:sp>
         <p:nvSpPr>
-          <p:cNvPr id="22" name="TextBox 21"/>
+          <p:cNvPr id="26" name="TextBox 25"/>
           <p:cNvSpPr txBox="1"/>
           <p:nvPr/>
         </p:nvSpPr>
@@ -10478,6 +11224,9 @@
   <p:clrMapOvr>
     <a:masterClrMapping/>
   </p:clrMapOvr>
+  <p:transition xmlns:p14="http://schemas.microsoft.com/office/powerpoint/2010/main" spd="med" dur="1500">
+    <p14:morph option="byObject"/>
+  </p:transition>
 </p:sld>
 </file>
 
@@ -10782,7 +11531,50 @@
       </p:sp>
       <p:sp>
         <p:nvSpPr>
-          <p:cNvPr id="8" name="TextBox 7"/>
+          <p:cNvPr id="8" name="Rectangle 7"/>
+          <p:cNvSpPr/>
+          <p:nvPr/>
+        </p:nvSpPr>
+        <p:spPr>
+          <a:xfrm>
+            <a:off x="3017520" y="1536192"/>
+            <a:ext cx="137160" cy="18288"/>
+          </a:xfrm>
+          <a:prstGeom prst="rect">
+            <a:avLst/>
+          </a:prstGeom>
+          <a:solidFill>
+            <a:srgbClr val="2E364A"/>
+          </a:solidFill>
+          <a:ln>
+            <a:noFill/>
+          </a:ln>
+        </p:spPr>
+        <p:style>
+          <a:lnRef idx="1">
+            <a:schemeClr val="accent1"/>
+          </a:lnRef>
+          <a:fillRef idx="3">
+            <a:schemeClr val="accent1"/>
+          </a:fillRef>
+          <a:effectRef idx="2">
+            <a:schemeClr val="accent1"/>
+          </a:effectRef>
+          <a:fontRef idx="minor">
+            <a:schemeClr val="lt1"/>
+          </a:fontRef>
+        </p:style>
+        <p:txBody>
+          <a:bodyPr rtlCol="0" anchor="ctr"/>
+          <a:lstStyle/>
+          <a:p>
+            <a:pPr algn="ctr"/>
+          </a:p>
+        </p:txBody>
+      </p:sp>
+      <p:sp>
+        <p:nvSpPr>
+          <p:cNvPr id="9" name="TextBox 8"/>
           <p:cNvSpPr txBox="1"/>
           <p:nvPr/>
         </p:nvSpPr>
@@ -10818,7 +11610,7 @@
       </p:sp>
       <p:sp>
         <p:nvSpPr>
-          <p:cNvPr id="9" name="Oval 8"/>
+          <p:cNvPr id="10" name="Oval 9"/>
           <p:cNvSpPr/>
           <p:nvPr/>
         </p:nvSpPr>
@@ -10873,7 +11665,7 @@
       </p:sp>
       <p:sp>
         <p:nvSpPr>
-          <p:cNvPr id="10" name="TextBox 9"/>
+          <p:cNvPr id="11" name="TextBox 10"/>
           <p:cNvSpPr txBox="1"/>
           <p:nvPr/>
         </p:nvSpPr>
@@ -10909,7 +11701,7 @@
       </p:sp>
       <p:sp>
         <p:nvSpPr>
-          <p:cNvPr id="11" name="Rounded Rectangle 10"/>
+          <p:cNvPr id="12" name="Rounded Rectangle 11"/>
           <p:cNvSpPr/>
           <p:nvPr/>
         </p:nvSpPr>
@@ -10954,7 +11746,50 @@
       </p:sp>
       <p:sp>
         <p:nvSpPr>
-          <p:cNvPr id="12" name="TextBox 11"/>
+          <p:cNvPr id="13" name="Rectangle 12"/>
+          <p:cNvSpPr/>
+          <p:nvPr/>
+        </p:nvSpPr>
+        <p:spPr>
+          <a:xfrm>
+            <a:off x="5760720" y="1536192"/>
+            <a:ext cx="137160" cy="18288"/>
+          </a:xfrm>
+          <a:prstGeom prst="rect">
+            <a:avLst/>
+          </a:prstGeom>
+          <a:solidFill>
+            <a:srgbClr val="2E364A"/>
+          </a:solidFill>
+          <a:ln>
+            <a:noFill/>
+          </a:ln>
+        </p:spPr>
+        <p:style>
+          <a:lnRef idx="1">
+            <a:schemeClr val="accent1"/>
+          </a:lnRef>
+          <a:fillRef idx="3">
+            <a:schemeClr val="accent1"/>
+          </a:fillRef>
+          <a:effectRef idx="2">
+            <a:schemeClr val="accent1"/>
+          </a:effectRef>
+          <a:fontRef idx="minor">
+            <a:schemeClr val="lt1"/>
+          </a:fontRef>
+        </p:style>
+        <p:txBody>
+          <a:bodyPr rtlCol="0" anchor="ctr"/>
+          <a:lstStyle/>
+          <a:p>
+            <a:pPr algn="ctr"/>
+          </a:p>
+        </p:txBody>
+      </p:sp>
+      <p:sp>
+        <p:nvSpPr>
+          <p:cNvPr id="14" name="TextBox 13"/>
           <p:cNvSpPr txBox="1"/>
           <p:nvPr/>
         </p:nvSpPr>
@@ -10990,7 +11825,7 @@
       </p:sp>
       <p:sp>
         <p:nvSpPr>
-          <p:cNvPr id="13" name="Oval 12"/>
+          <p:cNvPr id="15" name="Oval 14"/>
           <p:cNvSpPr/>
           <p:nvPr/>
         </p:nvSpPr>
@@ -11045,7 +11880,7 @@
       </p:sp>
       <p:sp>
         <p:nvSpPr>
-          <p:cNvPr id="14" name="TextBox 13"/>
+          <p:cNvPr id="16" name="TextBox 15"/>
           <p:cNvSpPr txBox="1"/>
           <p:nvPr/>
         </p:nvSpPr>
@@ -11081,7 +11916,7 @@
       </p:sp>
       <p:sp>
         <p:nvSpPr>
-          <p:cNvPr id="15" name="Rounded Rectangle 14"/>
+          <p:cNvPr id="17" name="Rounded Rectangle 16"/>
           <p:cNvSpPr/>
           <p:nvPr/>
         </p:nvSpPr>
@@ -11126,7 +11961,50 @@
       </p:sp>
       <p:sp>
         <p:nvSpPr>
-          <p:cNvPr id="16" name="TextBox 15"/>
+          <p:cNvPr id="18" name="Rectangle 17"/>
+          <p:cNvSpPr/>
+          <p:nvPr/>
+        </p:nvSpPr>
+        <p:spPr>
+          <a:xfrm>
+            <a:off x="8503920" y="1536192"/>
+            <a:ext cx="137160" cy="18288"/>
+          </a:xfrm>
+          <a:prstGeom prst="rect">
+            <a:avLst/>
+          </a:prstGeom>
+          <a:solidFill>
+            <a:srgbClr val="2E364A"/>
+          </a:solidFill>
+          <a:ln>
+            <a:noFill/>
+          </a:ln>
+        </p:spPr>
+        <p:style>
+          <a:lnRef idx="1">
+            <a:schemeClr val="accent1"/>
+          </a:lnRef>
+          <a:fillRef idx="3">
+            <a:schemeClr val="accent1"/>
+          </a:fillRef>
+          <a:effectRef idx="2">
+            <a:schemeClr val="accent1"/>
+          </a:effectRef>
+          <a:fontRef idx="minor">
+            <a:schemeClr val="lt1"/>
+          </a:fontRef>
+        </p:style>
+        <p:txBody>
+          <a:bodyPr rtlCol="0" anchor="ctr"/>
+          <a:lstStyle/>
+          <a:p>
+            <a:pPr algn="ctr"/>
+          </a:p>
+        </p:txBody>
+      </p:sp>
+      <p:sp>
+        <p:nvSpPr>
+          <p:cNvPr id="19" name="TextBox 18"/>
           <p:cNvSpPr txBox="1"/>
           <p:nvPr/>
         </p:nvSpPr>
@@ -11162,7 +12040,7 @@
       </p:sp>
       <p:sp>
         <p:nvSpPr>
-          <p:cNvPr id="17" name="Oval 16"/>
+          <p:cNvPr id="20" name="Oval 19"/>
           <p:cNvSpPr/>
           <p:nvPr/>
         </p:nvSpPr>
@@ -11217,7 +12095,7 @@
       </p:sp>
       <p:sp>
         <p:nvSpPr>
-          <p:cNvPr id="18" name="TextBox 17"/>
+          <p:cNvPr id="21" name="TextBox 20"/>
           <p:cNvSpPr txBox="1"/>
           <p:nvPr/>
         </p:nvSpPr>
@@ -11253,7 +12131,7 @@
       </p:sp>
       <p:sp>
         <p:nvSpPr>
-          <p:cNvPr id="19" name="Rounded Rectangle 18"/>
+          <p:cNvPr id="22" name="Rounded Rectangle 21"/>
           <p:cNvSpPr/>
           <p:nvPr/>
         </p:nvSpPr>
@@ -11298,7 +12176,50 @@
       </p:sp>
       <p:sp>
         <p:nvSpPr>
-          <p:cNvPr id="20" name="TextBox 19"/>
+          <p:cNvPr id="23" name="Rectangle 22"/>
+          <p:cNvSpPr/>
+          <p:nvPr/>
+        </p:nvSpPr>
+        <p:spPr>
+          <a:xfrm>
+            <a:off x="11247120" y="1536192"/>
+            <a:ext cx="137160" cy="18288"/>
+          </a:xfrm>
+          <a:prstGeom prst="rect">
+            <a:avLst/>
+          </a:prstGeom>
+          <a:solidFill>
+            <a:srgbClr val="2E364A"/>
+          </a:solidFill>
+          <a:ln>
+            <a:noFill/>
+          </a:ln>
+        </p:spPr>
+        <p:style>
+          <a:lnRef idx="1">
+            <a:schemeClr val="accent1"/>
+          </a:lnRef>
+          <a:fillRef idx="3">
+            <a:schemeClr val="accent1"/>
+          </a:fillRef>
+          <a:effectRef idx="2">
+            <a:schemeClr val="accent1"/>
+          </a:effectRef>
+          <a:fontRef idx="minor">
+            <a:schemeClr val="lt1"/>
+          </a:fontRef>
+        </p:style>
+        <p:txBody>
+          <a:bodyPr rtlCol="0" anchor="ctr"/>
+          <a:lstStyle/>
+          <a:p>
+            <a:pPr algn="ctr"/>
+          </a:p>
+        </p:txBody>
+      </p:sp>
+      <p:sp>
+        <p:nvSpPr>
+          <p:cNvPr id="24" name="TextBox 23"/>
           <p:cNvSpPr txBox="1"/>
           <p:nvPr/>
         </p:nvSpPr>
@@ -11334,7 +12255,7 @@
       </p:sp>
       <p:sp>
         <p:nvSpPr>
-          <p:cNvPr id="21" name="Oval 20"/>
+          <p:cNvPr id="25" name="Oval 24"/>
           <p:cNvSpPr/>
           <p:nvPr/>
         </p:nvSpPr>
@@ -11389,7 +12310,7 @@
       </p:sp>
       <p:sp>
         <p:nvSpPr>
-          <p:cNvPr id="22" name="TextBox 21"/>
+          <p:cNvPr id="26" name="TextBox 25"/>
           <p:cNvSpPr txBox="1"/>
           <p:nvPr/>
         </p:nvSpPr>
@@ -11425,7 +12346,7 @@
       </p:sp>
       <p:sp>
         <p:nvSpPr>
-          <p:cNvPr id="23" name="Rounded Rectangle 22"/>
+          <p:cNvPr id="27" name="Rounded Rectangle 26"/>
           <p:cNvSpPr/>
           <p:nvPr/>
         </p:nvSpPr>
@@ -11470,7 +12391,7 @@
       </p:sp>
       <p:sp>
         <p:nvSpPr>
-          <p:cNvPr id="24" name="Rounded Rectangle 23"/>
+          <p:cNvPr id="28" name="Rounded Rectangle 27"/>
           <p:cNvSpPr/>
           <p:nvPr/>
         </p:nvSpPr>
@@ -11513,7 +12434,50 @@
       </p:sp>
       <p:sp>
         <p:nvSpPr>
-          <p:cNvPr id="25" name="TextBox 24"/>
+          <p:cNvPr id="29" name="Rectangle 28"/>
+          <p:cNvSpPr/>
+          <p:nvPr/>
+        </p:nvSpPr>
+        <p:spPr>
+          <a:xfrm>
+            <a:off x="11231575" y="4279392"/>
+            <a:ext cx="137160" cy="18288"/>
+          </a:xfrm>
+          <a:prstGeom prst="rect">
+            <a:avLst/>
+          </a:prstGeom>
+          <a:solidFill>
+            <a:srgbClr val="34D399"/>
+          </a:solidFill>
+          <a:ln>
+            <a:noFill/>
+          </a:ln>
+        </p:spPr>
+        <p:style>
+          <a:lnRef idx="1">
+            <a:schemeClr val="accent1"/>
+          </a:lnRef>
+          <a:fillRef idx="3">
+            <a:schemeClr val="accent1"/>
+          </a:fillRef>
+          <a:effectRef idx="2">
+            <a:schemeClr val="accent1"/>
+          </a:effectRef>
+          <a:fontRef idx="minor">
+            <a:schemeClr val="lt1"/>
+          </a:fontRef>
+        </p:style>
+        <p:txBody>
+          <a:bodyPr rtlCol="0" anchor="ctr"/>
+          <a:lstStyle/>
+          <a:p>
+            <a:pPr algn="ctr"/>
+          </a:p>
+        </p:txBody>
+      </p:sp>
+      <p:sp>
+        <p:nvSpPr>
+          <p:cNvPr id="30" name="TextBox 29"/>
           <p:cNvSpPr txBox="1"/>
           <p:nvPr/>
         </p:nvSpPr>
@@ -11549,7 +12513,7 @@
       </p:sp>
       <p:sp>
         <p:nvSpPr>
-          <p:cNvPr id="26" name="Oval 25"/>
+          <p:cNvPr id="31" name="Oval 30"/>
           <p:cNvSpPr/>
           <p:nvPr/>
         </p:nvSpPr>
@@ -11604,7 +12568,7 @@
       </p:sp>
       <p:sp>
         <p:nvSpPr>
-          <p:cNvPr id="27" name="TextBox 26"/>
+          <p:cNvPr id="32" name="TextBox 31"/>
           <p:cNvSpPr txBox="1"/>
           <p:nvPr/>
         </p:nvSpPr>
@@ -11640,7 +12604,7 @@
       </p:sp>
       <p:sp>
         <p:nvSpPr>
-          <p:cNvPr id="28" name="Rounded Rectangle 27"/>
+          <p:cNvPr id="33" name="Rounded Rectangle 32"/>
           <p:cNvSpPr/>
           <p:nvPr/>
         </p:nvSpPr>
@@ -11685,7 +12649,7 @@
       </p:sp>
       <p:sp>
         <p:nvSpPr>
-          <p:cNvPr id="29" name="Rounded Rectangle 28"/>
+          <p:cNvPr id="34" name="Rounded Rectangle 33"/>
           <p:cNvSpPr/>
           <p:nvPr/>
         </p:nvSpPr>
@@ -11728,7 +12692,50 @@
       </p:sp>
       <p:sp>
         <p:nvSpPr>
-          <p:cNvPr id="30" name="TextBox 29"/>
+          <p:cNvPr id="35" name="Rectangle 34"/>
+          <p:cNvSpPr/>
+          <p:nvPr/>
+        </p:nvSpPr>
+        <p:spPr>
+          <a:xfrm>
+            <a:off x="3886200" y="5376672"/>
+            <a:ext cx="137160" cy="18288"/>
+          </a:xfrm>
+          <a:prstGeom prst="rect">
+            <a:avLst/>
+          </a:prstGeom>
+          <a:solidFill>
+            <a:srgbClr val="38BDF8"/>
+          </a:solidFill>
+          <a:ln>
+            <a:noFill/>
+          </a:ln>
+        </p:spPr>
+        <p:style>
+          <a:lnRef idx="1">
+            <a:schemeClr val="accent1"/>
+          </a:lnRef>
+          <a:fillRef idx="3">
+            <a:schemeClr val="accent1"/>
+          </a:fillRef>
+          <a:effectRef idx="2">
+            <a:schemeClr val="accent1"/>
+          </a:effectRef>
+          <a:fontRef idx="minor">
+            <a:schemeClr val="lt1"/>
+          </a:fontRef>
+        </p:style>
+        <p:txBody>
+          <a:bodyPr rtlCol="0" anchor="ctr"/>
+          <a:lstStyle/>
+          <a:p>
+            <a:pPr algn="ctr"/>
+          </a:p>
+        </p:txBody>
+      </p:sp>
+      <p:sp>
+        <p:nvSpPr>
+          <p:cNvPr id="36" name="TextBox 35"/>
           <p:cNvSpPr txBox="1"/>
           <p:nvPr/>
         </p:nvSpPr>
@@ -11764,7 +12771,7 @@
       </p:sp>
       <p:sp>
         <p:nvSpPr>
-          <p:cNvPr id="31" name="TextBox 30"/>
+          <p:cNvPr id="37" name="TextBox 36"/>
           <p:cNvSpPr txBox="1"/>
           <p:nvPr/>
         </p:nvSpPr>
@@ -11800,7 +12807,7 @@
       </p:sp>
       <p:sp>
         <p:nvSpPr>
-          <p:cNvPr id="32" name="Rounded Rectangle 31"/>
+          <p:cNvPr id="38" name="Rounded Rectangle 37"/>
           <p:cNvSpPr/>
           <p:nvPr/>
         </p:nvSpPr>
@@ -11845,7 +12852,7 @@
       </p:sp>
       <p:sp>
         <p:nvSpPr>
-          <p:cNvPr id="33" name="Rounded Rectangle 32"/>
+          <p:cNvPr id="39" name="Rounded Rectangle 38"/>
           <p:cNvSpPr/>
           <p:nvPr/>
         </p:nvSpPr>
@@ -11888,7 +12895,50 @@
       </p:sp>
       <p:sp>
         <p:nvSpPr>
-          <p:cNvPr id="34" name="TextBox 33"/>
+          <p:cNvPr id="40" name="Rectangle 39"/>
+          <p:cNvSpPr/>
+          <p:nvPr/>
+        </p:nvSpPr>
+        <p:spPr>
+          <a:xfrm>
+            <a:off x="7543800" y="5376672"/>
+            <a:ext cx="137160" cy="18288"/>
+          </a:xfrm>
+          <a:prstGeom prst="rect">
+            <a:avLst/>
+          </a:prstGeom>
+          <a:solidFill>
+            <a:srgbClr val="818CF8"/>
+          </a:solidFill>
+          <a:ln>
+            <a:noFill/>
+          </a:ln>
+        </p:spPr>
+        <p:style>
+          <a:lnRef idx="1">
+            <a:schemeClr val="accent1"/>
+          </a:lnRef>
+          <a:fillRef idx="3">
+            <a:schemeClr val="accent1"/>
+          </a:fillRef>
+          <a:effectRef idx="2">
+            <a:schemeClr val="accent1"/>
+          </a:effectRef>
+          <a:fontRef idx="minor">
+            <a:schemeClr val="lt1"/>
+          </a:fontRef>
+        </p:style>
+        <p:txBody>
+          <a:bodyPr rtlCol="0" anchor="ctr"/>
+          <a:lstStyle/>
+          <a:p>
+            <a:pPr algn="ctr"/>
+          </a:p>
+        </p:txBody>
+      </p:sp>
+      <p:sp>
+        <p:nvSpPr>
+          <p:cNvPr id="41" name="TextBox 40"/>
           <p:cNvSpPr txBox="1"/>
           <p:nvPr/>
         </p:nvSpPr>
@@ -11924,7 +12974,7 @@
       </p:sp>
       <p:sp>
         <p:nvSpPr>
-          <p:cNvPr id="35" name="TextBox 34"/>
+          <p:cNvPr id="42" name="TextBox 41"/>
           <p:cNvSpPr txBox="1"/>
           <p:nvPr/>
         </p:nvSpPr>
@@ -11960,7 +13010,7 @@
       </p:sp>
       <p:sp>
         <p:nvSpPr>
-          <p:cNvPr id="36" name="Rounded Rectangle 35"/>
+          <p:cNvPr id="43" name="Rounded Rectangle 42"/>
           <p:cNvSpPr/>
           <p:nvPr/>
         </p:nvSpPr>
@@ -12005,7 +13055,7 @@
       </p:sp>
       <p:sp>
         <p:nvSpPr>
-          <p:cNvPr id="37" name="Rounded Rectangle 36"/>
+          <p:cNvPr id="44" name="Rounded Rectangle 43"/>
           <p:cNvSpPr/>
           <p:nvPr/>
         </p:nvSpPr>
@@ -12048,7 +13098,50 @@
       </p:sp>
       <p:sp>
         <p:nvSpPr>
-          <p:cNvPr id="38" name="TextBox 37"/>
+          <p:cNvPr id="45" name="Rectangle 44"/>
+          <p:cNvSpPr/>
+          <p:nvPr/>
+        </p:nvSpPr>
+        <p:spPr>
+          <a:xfrm>
+            <a:off x="11201400" y="5376672"/>
+            <a:ext cx="137160" cy="18288"/>
+          </a:xfrm>
+          <a:prstGeom prst="rect">
+            <a:avLst/>
+          </a:prstGeom>
+          <a:solidFill>
+            <a:srgbClr val="34D399"/>
+          </a:solidFill>
+          <a:ln>
+            <a:noFill/>
+          </a:ln>
+        </p:spPr>
+        <p:style>
+          <a:lnRef idx="1">
+            <a:schemeClr val="accent1"/>
+          </a:lnRef>
+          <a:fillRef idx="3">
+            <a:schemeClr val="accent1"/>
+          </a:fillRef>
+          <a:effectRef idx="2">
+            <a:schemeClr val="accent1"/>
+          </a:effectRef>
+          <a:fontRef idx="minor">
+            <a:schemeClr val="lt1"/>
+          </a:fontRef>
+        </p:style>
+        <p:txBody>
+          <a:bodyPr rtlCol="0" anchor="ctr"/>
+          <a:lstStyle/>
+          <a:p>
+            <a:pPr algn="ctr"/>
+          </a:p>
+        </p:txBody>
+      </p:sp>
+      <p:sp>
+        <p:nvSpPr>
+          <p:cNvPr id="46" name="TextBox 45"/>
           <p:cNvSpPr txBox="1"/>
           <p:nvPr/>
         </p:nvSpPr>
@@ -12084,7 +13177,7 @@
       </p:sp>
       <p:sp>
         <p:nvSpPr>
-          <p:cNvPr id="39" name="TextBox 38"/>
+          <p:cNvPr id="47" name="TextBox 46"/>
           <p:cNvSpPr txBox="1"/>
           <p:nvPr/>
         </p:nvSpPr>
@@ -12123,6 +13216,9 @@
   <p:clrMapOvr>
     <a:masterClrMapping/>
   </p:clrMapOvr>
+  <p:transition xmlns:p14="http://schemas.microsoft.com/office/powerpoint/2010/main" spd="med" dur="1500">
+    <p14:morph option="byObject"/>
+  </p:transition>
 </p:sld>
 </file>
 
@@ -12646,7 +13742,50 @@
       </p:sp>
       <p:sp>
         <p:nvSpPr>
-          <p:cNvPr id="11" name="TextBox 10"/>
+          <p:cNvPr id="11" name="Rectangle 10"/>
+          <p:cNvSpPr/>
+          <p:nvPr/>
+        </p:nvSpPr>
+        <p:spPr>
+          <a:xfrm>
+            <a:off x="3886200" y="4462272"/>
+            <a:ext cx="137160" cy="18288"/>
+          </a:xfrm>
+          <a:prstGeom prst="rect">
+            <a:avLst/>
+          </a:prstGeom>
+          <a:solidFill>
+            <a:srgbClr val="38BDF8"/>
+          </a:solidFill>
+          <a:ln>
+            <a:noFill/>
+          </a:ln>
+        </p:spPr>
+        <p:style>
+          <a:lnRef idx="1">
+            <a:schemeClr val="accent1"/>
+          </a:lnRef>
+          <a:fillRef idx="3">
+            <a:schemeClr val="accent1"/>
+          </a:fillRef>
+          <a:effectRef idx="2">
+            <a:schemeClr val="accent1"/>
+          </a:effectRef>
+          <a:fontRef idx="minor">
+            <a:schemeClr val="lt1"/>
+          </a:fontRef>
+        </p:style>
+        <p:txBody>
+          <a:bodyPr rtlCol="0" anchor="ctr"/>
+          <a:lstStyle/>
+          <a:p>
+            <a:pPr algn="ctr"/>
+          </a:p>
+        </p:txBody>
+      </p:sp>
+      <p:sp>
+        <p:nvSpPr>
+          <p:cNvPr id="12" name="TextBox 11"/>
           <p:cNvSpPr txBox="1"/>
           <p:nvPr/>
         </p:nvSpPr>
@@ -12682,7 +13821,7 @@
       </p:sp>
       <p:sp>
         <p:nvSpPr>
-          <p:cNvPr id="12" name="TextBox 11"/>
+          <p:cNvPr id="13" name="TextBox 12"/>
           <p:cNvSpPr txBox="1"/>
           <p:nvPr/>
         </p:nvSpPr>
@@ -12718,7 +13857,7 @@
       </p:sp>
       <p:sp>
         <p:nvSpPr>
-          <p:cNvPr id="13" name="Rounded Rectangle 12"/>
+          <p:cNvPr id="14" name="Rounded Rectangle 13"/>
           <p:cNvSpPr/>
           <p:nvPr/>
         </p:nvSpPr>
@@ -12763,7 +13902,7 @@
       </p:sp>
       <p:sp>
         <p:nvSpPr>
-          <p:cNvPr id="14" name="Rounded Rectangle 13"/>
+          <p:cNvPr id="15" name="Rounded Rectangle 14"/>
           <p:cNvSpPr/>
           <p:nvPr/>
         </p:nvSpPr>
@@ -12806,7 +13945,50 @@
       </p:sp>
       <p:sp>
         <p:nvSpPr>
-          <p:cNvPr id="15" name="TextBox 14"/>
+          <p:cNvPr id="16" name="Rectangle 15"/>
+          <p:cNvSpPr/>
+          <p:nvPr/>
+        </p:nvSpPr>
+        <p:spPr>
+          <a:xfrm>
+            <a:off x="7543800" y="4462272"/>
+            <a:ext cx="137160" cy="18288"/>
+          </a:xfrm>
+          <a:prstGeom prst="rect">
+            <a:avLst/>
+          </a:prstGeom>
+          <a:solidFill>
+            <a:srgbClr val="34D399"/>
+          </a:solidFill>
+          <a:ln>
+            <a:noFill/>
+          </a:ln>
+        </p:spPr>
+        <p:style>
+          <a:lnRef idx="1">
+            <a:schemeClr val="accent1"/>
+          </a:lnRef>
+          <a:fillRef idx="3">
+            <a:schemeClr val="accent1"/>
+          </a:fillRef>
+          <a:effectRef idx="2">
+            <a:schemeClr val="accent1"/>
+          </a:effectRef>
+          <a:fontRef idx="minor">
+            <a:schemeClr val="lt1"/>
+          </a:fontRef>
+        </p:style>
+        <p:txBody>
+          <a:bodyPr rtlCol="0" anchor="ctr"/>
+          <a:lstStyle/>
+          <a:p>
+            <a:pPr algn="ctr"/>
+          </a:p>
+        </p:txBody>
+      </p:sp>
+      <p:sp>
+        <p:nvSpPr>
+          <p:cNvPr id="17" name="TextBox 16"/>
           <p:cNvSpPr txBox="1"/>
           <p:nvPr/>
         </p:nvSpPr>
@@ -12842,7 +14024,7 @@
       </p:sp>
       <p:sp>
         <p:nvSpPr>
-          <p:cNvPr id="16" name="TextBox 15"/>
+          <p:cNvPr id="18" name="TextBox 17"/>
           <p:cNvSpPr txBox="1"/>
           <p:nvPr/>
         </p:nvSpPr>
@@ -12878,7 +14060,7 @@
       </p:sp>
       <p:sp>
         <p:nvSpPr>
-          <p:cNvPr id="17" name="Rounded Rectangle 16"/>
+          <p:cNvPr id="19" name="Rounded Rectangle 18"/>
           <p:cNvSpPr/>
           <p:nvPr/>
         </p:nvSpPr>
@@ -12923,7 +14105,7 @@
       </p:sp>
       <p:sp>
         <p:nvSpPr>
-          <p:cNvPr id="18" name="Rounded Rectangle 17"/>
+          <p:cNvPr id="20" name="Rounded Rectangle 19"/>
           <p:cNvSpPr/>
           <p:nvPr/>
         </p:nvSpPr>
@@ -12966,7 +14148,50 @@
       </p:sp>
       <p:sp>
         <p:nvSpPr>
-          <p:cNvPr id="19" name="TextBox 18"/>
+          <p:cNvPr id="21" name="Rectangle 20"/>
+          <p:cNvSpPr/>
+          <p:nvPr/>
+        </p:nvSpPr>
+        <p:spPr>
+          <a:xfrm>
+            <a:off x="11201400" y="4462272"/>
+            <a:ext cx="137160" cy="18288"/>
+          </a:xfrm>
+          <a:prstGeom prst="rect">
+            <a:avLst/>
+          </a:prstGeom>
+          <a:solidFill>
+            <a:srgbClr val="818CF8"/>
+          </a:solidFill>
+          <a:ln>
+            <a:noFill/>
+          </a:ln>
+        </p:spPr>
+        <p:style>
+          <a:lnRef idx="1">
+            <a:schemeClr val="accent1"/>
+          </a:lnRef>
+          <a:fillRef idx="3">
+            <a:schemeClr val="accent1"/>
+          </a:fillRef>
+          <a:effectRef idx="2">
+            <a:schemeClr val="accent1"/>
+          </a:effectRef>
+          <a:fontRef idx="minor">
+            <a:schemeClr val="lt1"/>
+          </a:fontRef>
+        </p:style>
+        <p:txBody>
+          <a:bodyPr rtlCol="0" anchor="ctr"/>
+          <a:lstStyle/>
+          <a:p>
+            <a:pPr algn="ctr"/>
+          </a:p>
+        </p:txBody>
+      </p:sp>
+      <p:sp>
+        <p:nvSpPr>
+          <p:cNvPr id="22" name="TextBox 21"/>
           <p:cNvSpPr txBox="1"/>
           <p:nvPr/>
         </p:nvSpPr>
@@ -13002,7 +14227,7 @@
       </p:sp>
       <p:sp>
         <p:nvSpPr>
-          <p:cNvPr id="20" name="TextBox 19"/>
+          <p:cNvPr id="23" name="TextBox 22"/>
           <p:cNvSpPr txBox="1"/>
           <p:nvPr/>
         </p:nvSpPr>
@@ -13041,6 +14266,9 @@
   <p:clrMapOvr>
     <a:masterClrMapping/>
   </p:clrMapOvr>
+  <p:transition xmlns:p14="http://schemas.microsoft.com/office/powerpoint/2010/main" spd="med" dur="1500">
+    <p14:morph option="byObject"/>
+  </p:transition>
 </p:sld>
 </file>
 
@@ -13512,7 +14740,50 @@
       </p:sp>
       <p:sp>
         <p:nvSpPr>
-          <p:cNvPr id="11" name="TextBox 10"/>
+          <p:cNvPr id="11" name="Rectangle 10"/>
+          <p:cNvSpPr/>
+          <p:nvPr/>
+        </p:nvSpPr>
+        <p:spPr>
+          <a:xfrm>
+            <a:off x="11201400" y="3913632"/>
+            <a:ext cx="137160" cy="18288"/>
+          </a:xfrm>
+          <a:prstGeom prst="rect">
+            <a:avLst/>
+          </a:prstGeom>
+          <a:solidFill>
+            <a:srgbClr val="38BDF8"/>
+          </a:solidFill>
+          <a:ln>
+            <a:noFill/>
+          </a:ln>
+        </p:spPr>
+        <p:style>
+          <a:lnRef idx="1">
+            <a:schemeClr val="accent1"/>
+          </a:lnRef>
+          <a:fillRef idx="3">
+            <a:schemeClr val="accent1"/>
+          </a:fillRef>
+          <a:effectRef idx="2">
+            <a:schemeClr val="accent1"/>
+          </a:effectRef>
+          <a:fontRef idx="minor">
+            <a:schemeClr val="lt1"/>
+          </a:fontRef>
+        </p:style>
+        <p:txBody>
+          <a:bodyPr rtlCol="0" anchor="ctr"/>
+          <a:lstStyle/>
+          <a:p>
+            <a:pPr algn="ctr"/>
+          </a:p>
+        </p:txBody>
+      </p:sp>
+      <p:sp>
+        <p:nvSpPr>
+          <p:cNvPr id="12" name="TextBox 11"/>
           <p:cNvSpPr txBox="1"/>
           <p:nvPr/>
         </p:nvSpPr>
@@ -13548,7 +14819,7 @@
       </p:sp>
       <p:sp>
         <p:nvSpPr>
-          <p:cNvPr id="12" name="TextBox 11"/>
+          <p:cNvPr id="13" name="TextBox 12"/>
           <p:cNvSpPr txBox="1"/>
           <p:nvPr/>
         </p:nvSpPr>
@@ -13584,7 +14855,7 @@
       </p:sp>
       <p:sp>
         <p:nvSpPr>
-          <p:cNvPr id="13" name="Rounded Rectangle 12"/>
+          <p:cNvPr id="14" name="Rounded Rectangle 13"/>
           <p:cNvSpPr/>
           <p:nvPr/>
         </p:nvSpPr>
@@ -13629,7 +14900,7 @@
       </p:sp>
       <p:sp>
         <p:nvSpPr>
-          <p:cNvPr id="14" name="Rounded Rectangle 13"/>
+          <p:cNvPr id="15" name="Rounded Rectangle 14"/>
           <p:cNvSpPr/>
           <p:nvPr/>
         </p:nvSpPr>
@@ -13672,7 +14943,50 @@
       </p:sp>
       <p:sp>
         <p:nvSpPr>
-          <p:cNvPr id="15" name="TextBox 14"/>
+          <p:cNvPr id="16" name="Rectangle 15"/>
+          <p:cNvSpPr/>
+          <p:nvPr/>
+        </p:nvSpPr>
+        <p:spPr>
+          <a:xfrm>
+            <a:off x="11201400" y="4828032"/>
+            <a:ext cx="137160" cy="18288"/>
+          </a:xfrm>
+          <a:prstGeom prst="rect">
+            <a:avLst/>
+          </a:prstGeom>
+          <a:solidFill>
+            <a:srgbClr val="818CF8"/>
+          </a:solidFill>
+          <a:ln>
+            <a:noFill/>
+          </a:ln>
+        </p:spPr>
+        <p:style>
+          <a:lnRef idx="1">
+            <a:schemeClr val="accent1"/>
+          </a:lnRef>
+          <a:fillRef idx="3">
+            <a:schemeClr val="accent1"/>
+          </a:fillRef>
+          <a:effectRef idx="2">
+            <a:schemeClr val="accent1"/>
+          </a:effectRef>
+          <a:fontRef idx="minor">
+            <a:schemeClr val="lt1"/>
+          </a:fontRef>
+        </p:style>
+        <p:txBody>
+          <a:bodyPr rtlCol="0" anchor="ctr"/>
+          <a:lstStyle/>
+          <a:p>
+            <a:pPr algn="ctr"/>
+          </a:p>
+        </p:txBody>
+      </p:sp>
+      <p:sp>
+        <p:nvSpPr>
+          <p:cNvPr id="17" name="TextBox 16"/>
           <p:cNvSpPr txBox="1"/>
           <p:nvPr/>
         </p:nvSpPr>
@@ -13708,7 +15022,7 @@
       </p:sp>
       <p:sp>
         <p:nvSpPr>
-          <p:cNvPr id="16" name="TextBox 15"/>
+          <p:cNvPr id="18" name="TextBox 17"/>
           <p:cNvSpPr txBox="1"/>
           <p:nvPr/>
         </p:nvSpPr>
@@ -13744,7 +15058,7 @@
       </p:sp>
       <p:sp>
         <p:nvSpPr>
-          <p:cNvPr id="17" name="Rounded Rectangle 16"/>
+          <p:cNvPr id="19" name="Rounded Rectangle 18"/>
           <p:cNvSpPr/>
           <p:nvPr/>
         </p:nvSpPr>
@@ -13789,7 +15103,7 @@
       </p:sp>
       <p:sp>
         <p:nvSpPr>
-          <p:cNvPr id="18" name="Rounded Rectangle 17"/>
+          <p:cNvPr id="20" name="Rounded Rectangle 19"/>
           <p:cNvSpPr/>
           <p:nvPr/>
         </p:nvSpPr>
@@ -13832,7 +15146,50 @@
       </p:sp>
       <p:sp>
         <p:nvSpPr>
-          <p:cNvPr id="19" name="TextBox 18"/>
+          <p:cNvPr id="21" name="Rectangle 20"/>
+          <p:cNvSpPr/>
+          <p:nvPr/>
+        </p:nvSpPr>
+        <p:spPr>
+          <a:xfrm>
+            <a:off x="11201400" y="5742432"/>
+            <a:ext cx="137160" cy="18288"/>
+          </a:xfrm>
+          <a:prstGeom prst="rect">
+            <a:avLst/>
+          </a:prstGeom>
+          <a:solidFill>
+            <a:srgbClr val="34D399"/>
+          </a:solidFill>
+          <a:ln>
+            <a:noFill/>
+          </a:ln>
+        </p:spPr>
+        <p:style>
+          <a:lnRef idx="1">
+            <a:schemeClr val="accent1"/>
+          </a:lnRef>
+          <a:fillRef idx="3">
+            <a:schemeClr val="accent1"/>
+          </a:fillRef>
+          <a:effectRef idx="2">
+            <a:schemeClr val="accent1"/>
+          </a:effectRef>
+          <a:fontRef idx="minor">
+            <a:schemeClr val="lt1"/>
+          </a:fontRef>
+        </p:style>
+        <p:txBody>
+          <a:bodyPr rtlCol="0" anchor="ctr"/>
+          <a:lstStyle/>
+          <a:p>
+            <a:pPr algn="ctr"/>
+          </a:p>
+        </p:txBody>
+      </p:sp>
+      <p:sp>
+        <p:nvSpPr>
+          <p:cNvPr id="22" name="TextBox 21"/>
           <p:cNvSpPr txBox="1"/>
           <p:nvPr/>
         </p:nvSpPr>
@@ -13868,7 +15225,7 @@
       </p:sp>
       <p:sp>
         <p:nvSpPr>
-          <p:cNvPr id="20" name="TextBox 19"/>
+          <p:cNvPr id="23" name="TextBox 22"/>
           <p:cNvSpPr txBox="1"/>
           <p:nvPr/>
         </p:nvSpPr>
@@ -13907,6 +15264,9 @@
   <p:clrMapOvr>
     <a:masterClrMapping/>
   </p:clrMapOvr>
+  <p:transition xmlns:p14="http://schemas.microsoft.com/office/powerpoint/2010/main" spd="med" dur="1500">
+    <p14:morph option="byObject"/>
+  </p:transition>
 </p:sld>
 </file>
 
@@ -14383,7 +15743,50 @@
       </p:sp>
       <p:sp>
         <p:nvSpPr>
-          <p:cNvPr id="10" name="TextBox 9"/>
+          <p:cNvPr id="10" name="Rectangle 9"/>
+          <p:cNvSpPr/>
+          <p:nvPr/>
+        </p:nvSpPr>
+        <p:spPr>
+          <a:xfrm>
+            <a:off x="11231575" y="5879592"/>
+            <a:ext cx="137160" cy="18288"/>
+          </a:xfrm>
+          <a:prstGeom prst="rect">
+            <a:avLst/>
+          </a:prstGeom>
+          <a:solidFill>
+            <a:srgbClr val="2E364A"/>
+          </a:solidFill>
+          <a:ln>
+            <a:noFill/>
+          </a:ln>
+        </p:spPr>
+        <p:style>
+          <a:lnRef idx="1">
+            <a:schemeClr val="accent1"/>
+          </a:lnRef>
+          <a:fillRef idx="3">
+            <a:schemeClr val="accent1"/>
+          </a:fillRef>
+          <a:effectRef idx="2">
+            <a:schemeClr val="accent1"/>
+          </a:effectRef>
+          <a:fontRef idx="minor">
+            <a:schemeClr val="lt1"/>
+          </a:fontRef>
+        </p:style>
+        <p:txBody>
+          <a:bodyPr rtlCol="0" anchor="ctr"/>
+          <a:lstStyle/>
+          <a:p>
+            <a:pPr algn="ctr"/>
+          </a:p>
+        </p:txBody>
+      </p:sp>
+      <p:sp>
+        <p:nvSpPr>
+          <p:cNvPr id="11" name="TextBox 10"/>
           <p:cNvSpPr txBox="1"/>
           <p:nvPr/>
         </p:nvSpPr>
@@ -14429,6 +15832,9 @@
   <p:clrMapOvr>
     <a:masterClrMapping/>
   </p:clrMapOvr>
+  <p:transition xmlns:p14="http://schemas.microsoft.com/office/powerpoint/2010/main" spd="med" dur="1500">
+    <p14:morph option="byObject"/>
+  </p:transition>
 </p:sld>
 </file>
 
@@ -14776,7 +16182,50 @@
       </p:sp>
       <p:sp>
         <p:nvSpPr>
-          <p:cNvPr id="9" name="TextBox 8"/>
+          <p:cNvPr id="9" name="Rectangle 8"/>
+          <p:cNvSpPr/>
+          <p:nvPr/>
+        </p:nvSpPr>
+        <p:spPr>
+          <a:xfrm>
+            <a:off x="6172200" y="1536192"/>
+            <a:ext cx="137160" cy="18288"/>
+          </a:xfrm>
+          <a:prstGeom prst="rect">
+            <a:avLst/>
+          </a:prstGeom>
+          <a:solidFill>
+            <a:srgbClr val="38BDF8"/>
+          </a:solidFill>
+          <a:ln>
+            <a:noFill/>
+          </a:ln>
+        </p:spPr>
+        <p:style>
+          <a:lnRef idx="1">
+            <a:schemeClr val="accent1"/>
+          </a:lnRef>
+          <a:fillRef idx="3">
+            <a:schemeClr val="accent1"/>
+          </a:fillRef>
+          <a:effectRef idx="2">
+            <a:schemeClr val="accent1"/>
+          </a:effectRef>
+          <a:fontRef idx="minor">
+            <a:schemeClr val="lt1"/>
+          </a:fontRef>
+        </p:style>
+        <p:txBody>
+          <a:bodyPr rtlCol="0" anchor="ctr"/>
+          <a:lstStyle/>
+          <a:p>
+            <a:pPr algn="ctr"/>
+          </a:p>
+        </p:txBody>
+      </p:sp>
+      <p:sp>
+        <p:nvSpPr>
+          <p:cNvPr id="10" name="TextBox 9"/>
           <p:cNvSpPr txBox="1"/>
           <p:nvPr/>
         </p:nvSpPr>
@@ -14812,7 +16261,7 @@
       </p:sp>
       <p:sp>
         <p:nvSpPr>
-          <p:cNvPr id="10" name="TextBox 9"/>
+          <p:cNvPr id="11" name="TextBox 10"/>
           <p:cNvSpPr txBox="1"/>
           <p:nvPr/>
         </p:nvSpPr>
@@ -14848,7 +16297,7 @@
       </p:sp>
       <p:sp>
         <p:nvSpPr>
-          <p:cNvPr id="11" name="Rounded Rectangle 10"/>
+          <p:cNvPr id="12" name="Rounded Rectangle 11"/>
           <p:cNvSpPr/>
           <p:nvPr/>
         </p:nvSpPr>
@@ -14893,7 +16342,7 @@
       </p:sp>
       <p:sp>
         <p:nvSpPr>
-          <p:cNvPr id="12" name="Rounded Rectangle 11"/>
+          <p:cNvPr id="13" name="Rounded Rectangle 12"/>
           <p:cNvSpPr/>
           <p:nvPr/>
         </p:nvSpPr>
@@ -14936,7 +16385,50 @@
       </p:sp>
       <p:sp>
         <p:nvSpPr>
-          <p:cNvPr id="13" name="TextBox 12"/>
+          <p:cNvPr id="14" name="Rectangle 13"/>
+          <p:cNvSpPr/>
+          <p:nvPr/>
+        </p:nvSpPr>
+        <p:spPr>
+          <a:xfrm>
+            <a:off x="6172200" y="2724912"/>
+            <a:ext cx="137160" cy="18288"/>
+          </a:xfrm>
+          <a:prstGeom prst="rect">
+            <a:avLst/>
+          </a:prstGeom>
+          <a:solidFill>
+            <a:srgbClr val="34D399"/>
+          </a:solidFill>
+          <a:ln>
+            <a:noFill/>
+          </a:ln>
+        </p:spPr>
+        <p:style>
+          <a:lnRef idx="1">
+            <a:schemeClr val="accent1"/>
+          </a:lnRef>
+          <a:fillRef idx="3">
+            <a:schemeClr val="accent1"/>
+          </a:fillRef>
+          <a:effectRef idx="2">
+            <a:schemeClr val="accent1"/>
+          </a:effectRef>
+          <a:fontRef idx="minor">
+            <a:schemeClr val="lt1"/>
+          </a:fontRef>
+        </p:style>
+        <p:txBody>
+          <a:bodyPr rtlCol="0" anchor="ctr"/>
+          <a:lstStyle/>
+          <a:p>
+            <a:pPr algn="ctr"/>
+          </a:p>
+        </p:txBody>
+      </p:sp>
+      <p:sp>
+        <p:nvSpPr>
+          <p:cNvPr id="15" name="TextBox 14"/>
           <p:cNvSpPr txBox="1"/>
           <p:nvPr/>
         </p:nvSpPr>
@@ -14972,7 +16464,7 @@
       </p:sp>
       <p:sp>
         <p:nvSpPr>
-          <p:cNvPr id="14" name="TextBox 13"/>
+          <p:cNvPr id="16" name="TextBox 15"/>
           <p:cNvSpPr txBox="1"/>
           <p:nvPr/>
         </p:nvSpPr>
@@ -15008,7 +16500,7 @@
       </p:sp>
       <p:sp>
         <p:nvSpPr>
-          <p:cNvPr id="15" name="Rounded Rectangle 14"/>
+          <p:cNvPr id="17" name="Rounded Rectangle 16"/>
           <p:cNvSpPr/>
           <p:nvPr/>
         </p:nvSpPr>
@@ -15053,7 +16545,7 @@
       </p:sp>
       <p:sp>
         <p:nvSpPr>
-          <p:cNvPr id="16" name="Rounded Rectangle 15"/>
+          <p:cNvPr id="18" name="Rounded Rectangle 17"/>
           <p:cNvSpPr/>
           <p:nvPr/>
         </p:nvSpPr>
@@ -15096,7 +16588,50 @@
       </p:sp>
       <p:sp>
         <p:nvSpPr>
-          <p:cNvPr id="17" name="TextBox 16"/>
+          <p:cNvPr id="19" name="Rectangle 18"/>
+          <p:cNvSpPr/>
+          <p:nvPr/>
+        </p:nvSpPr>
+        <p:spPr>
+          <a:xfrm>
+            <a:off x="6172200" y="3913632"/>
+            <a:ext cx="137160" cy="18288"/>
+          </a:xfrm>
+          <a:prstGeom prst="rect">
+            <a:avLst/>
+          </a:prstGeom>
+          <a:solidFill>
+            <a:srgbClr val="818CF8"/>
+          </a:solidFill>
+          <a:ln>
+            <a:noFill/>
+          </a:ln>
+        </p:spPr>
+        <p:style>
+          <a:lnRef idx="1">
+            <a:schemeClr val="accent1"/>
+          </a:lnRef>
+          <a:fillRef idx="3">
+            <a:schemeClr val="accent1"/>
+          </a:fillRef>
+          <a:effectRef idx="2">
+            <a:schemeClr val="accent1"/>
+          </a:effectRef>
+          <a:fontRef idx="minor">
+            <a:schemeClr val="lt1"/>
+          </a:fontRef>
+        </p:style>
+        <p:txBody>
+          <a:bodyPr rtlCol="0" anchor="ctr"/>
+          <a:lstStyle/>
+          <a:p>
+            <a:pPr algn="ctr"/>
+          </a:p>
+        </p:txBody>
+      </p:sp>
+      <p:sp>
+        <p:nvSpPr>
+          <p:cNvPr id="20" name="TextBox 19"/>
           <p:cNvSpPr txBox="1"/>
           <p:nvPr/>
         </p:nvSpPr>
@@ -15132,7 +16667,7 @@
       </p:sp>
       <p:sp>
         <p:nvSpPr>
-          <p:cNvPr id="18" name="TextBox 17"/>
+          <p:cNvPr id="21" name="TextBox 20"/>
           <p:cNvSpPr txBox="1"/>
           <p:nvPr/>
         </p:nvSpPr>
@@ -15168,7 +16703,7 @@
       </p:sp>
       <p:sp>
         <p:nvSpPr>
-          <p:cNvPr id="19" name="Rounded Rectangle 18"/>
+          <p:cNvPr id="22" name="Rounded Rectangle 21"/>
           <p:cNvSpPr/>
           <p:nvPr/>
         </p:nvSpPr>
@@ -15213,7 +16748,7 @@
       </p:sp>
       <p:sp>
         <p:nvSpPr>
-          <p:cNvPr id="20" name="Rounded Rectangle 19"/>
+          <p:cNvPr id="23" name="Rounded Rectangle 22"/>
           <p:cNvSpPr/>
           <p:nvPr/>
         </p:nvSpPr>
@@ -15256,7 +16791,50 @@
       </p:sp>
       <p:sp>
         <p:nvSpPr>
-          <p:cNvPr id="21" name="TextBox 20"/>
+          <p:cNvPr id="24" name="Rectangle 23"/>
+          <p:cNvSpPr/>
+          <p:nvPr/>
+        </p:nvSpPr>
+        <p:spPr>
+          <a:xfrm>
+            <a:off x="6172200" y="5102352"/>
+            <a:ext cx="137160" cy="18288"/>
+          </a:xfrm>
+          <a:prstGeom prst="rect">
+            <a:avLst/>
+          </a:prstGeom>
+          <a:solidFill>
+            <a:srgbClr val="F59E0B"/>
+          </a:solidFill>
+          <a:ln>
+            <a:noFill/>
+          </a:ln>
+        </p:spPr>
+        <p:style>
+          <a:lnRef idx="1">
+            <a:schemeClr val="accent1"/>
+          </a:lnRef>
+          <a:fillRef idx="3">
+            <a:schemeClr val="accent1"/>
+          </a:fillRef>
+          <a:effectRef idx="2">
+            <a:schemeClr val="accent1"/>
+          </a:effectRef>
+          <a:fontRef idx="minor">
+            <a:schemeClr val="lt1"/>
+          </a:fontRef>
+        </p:style>
+        <p:txBody>
+          <a:bodyPr rtlCol="0" anchor="ctr"/>
+          <a:lstStyle/>
+          <a:p>
+            <a:pPr algn="ctr"/>
+          </a:p>
+        </p:txBody>
+      </p:sp>
+      <p:sp>
+        <p:nvSpPr>
+          <p:cNvPr id="25" name="TextBox 24"/>
           <p:cNvSpPr txBox="1"/>
           <p:nvPr/>
         </p:nvSpPr>
@@ -15292,7 +16870,7 @@
       </p:sp>
       <p:sp>
         <p:nvSpPr>
-          <p:cNvPr id="22" name="TextBox 21"/>
+          <p:cNvPr id="26" name="TextBox 25"/>
           <p:cNvSpPr txBox="1"/>
           <p:nvPr/>
         </p:nvSpPr>
@@ -15328,7 +16906,7 @@
       </p:sp>
       <p:pic>
         <p:nvPicPr>
-          <p:cNvPr id="23" name="Picture 22" descr="iso_multicore_chip.png"/>
+          <p:cNvPr id="27" name="Picture 26" descr="iso_multicore_chip.png"/>
           <p:cNvPicPr>
             <a:picLocks noChangeAspect="1"/>
           </p:cNvPicPr>
@@ -15355,6 +16933,9 @@
   <p:clrMapOvr>
     <a:masterClrMapping/>
   </p:clrMapOvr>
+  <p:transition xmlns:p14="http://schemas.microsoft.com/office/powerpoint/2010/main" spd="med" dur="1500">
+    <p14:morph option="byObject"/>
+  </p:transition>
 </p:sld>
 </file>
 
@@ -16311,7 +17892,50 @@
       </p:sp>
       <p:sp>
         <p:nvSpPr>
-          <p:cNvPr id="25" name="TextBox 24"/>
+          <p:cNvPr id="25" name="Rectangle 24"/>
+          <p:cNvSpPr/>
+          <p:nvPr/>
+        </p:nvSpPr>
+        <p:spPr>
+          <a:xfrm>
+            <a:off x="5806440" y="4096512"/>
+            <a:ext cx="137160" cy="18288"/>
+          </a:xfrm>
+          <a:prstGeom prst="rect">
+            <a:avLst/>
+          </a:prstGeom>
+          <a:solidFill>
+            <a:srgbClr val="818CF8"/>
+          </a:solidFill>
+          <a:ln>
+            <a:noFill/>
+          </a:ln>
+        </p:spPr>
+        <p:style>
+          <a:lnRef idx="1">
+            <a:schemeClr val="accent1"/>
+          </a:lnRef>
+          <a:fillRef idx="3">
+            <a:schemeClr val="accent1"/>
+          </a:fillRef>
+          <a:effectRef idx="2">
+            <a:schemeClr val="accent1"/>
+          </a:effectRef>
+          <a:fontRef idx="minor">
+            <a:schemeClr val="lt1"/>
+          </a:fontRef>
+        </p:style>
+        <p:txBody>
+          <a:bodyPr rtlCol="0" anchor="ctr"/>
+          <a:lstStyle/>
+          <a:p>
+            <a:pPr algn="ctr"/>
+          </a:p>
+        </p:txBody>
+      </p:sp>
+      <p:sp>
+        <p:nvSpPr>
+          <p:cNvPr id="26" name="TextBox 25"/>
           <p:cNvSpPr txBox="1"/>
           <p:nvPr/>
         </p:nvSpPr>
@@ -16347,7 +17971,7 @@
       </p:sp>
       <p:sp>
         <p:nvSpPr>
-          <p:cNvPr id="26" name="TextBox 25"/>
+          <p:cNvPr id="27" name="TextBox 26"/>
           <p:cNvSpPr txBox="1"/>
           <p:nvPr/>
         </p:nvSpPr>
@@ -16419,7 +18043,7 @@
       </p:sp>
       <p:sp>
         <p:nvSpPr>
-          <p:cNvPr id="27" name="Rounded Rectangle 26"/>
+          <p:cNvPr id="28" name="Rounded Rectangle 27"/>
           <p:cNvSpPr/>
           <p:nvPr/>
         </p:nvSpPr>
@@ -16464,7 +18088,7 @@
       </p:sp>
       <p:sp>
         <p:nvSpPr>
-          <p:cNvPr id="28" name="Rounded Rectangle 27"/>
+          <p:cNvPr id="29" name="Rounded Rectangle 28"/>
           <p:cNvSpPr/>
           <p:nvPr/>
         </p:nvSpPr>
@@ -16507,7 +18131,50 @@
       </p:sp>
       <p:sp>
         <p:nvSpPr>
-          <p:cNvPr id="29" name="TextBox 28"/>
+          <p:cNvPr id="30" name="Rectangle 29"/>
+          <p:cNvSpPr/>
+          <p:nvPr/>
+        </p:nvSpPr>
+        <p:spPr>
+          <a:xfrm>
+            <a:off x="11201400" y="1536192"/>
+            <a:ext cx="137160" cy="18288"/>
+          </a:xfrm>
+          <a:prstGeom prst="rect">
+            <a:avLst/>
+          </a:prstGeom>
+          <a:solidFill>
+            <a:srgbClr val="38BDF8"/>
+          </a:solidFill>
+          <a:ln>
+            <a:noFill/>
+          </a:ln>
+        </p:spPr>
+        <p:style>
+          <a:lnRef idx="1">
+            <a:schemeClr val="accent1"/>
+          </a:lnRef>
+          <a:fillRef idx="3">
+            <a:schemeClr val="accent1"/>
+          </a:fillRef>
+          <a:effectRef idx="2">
+            <a:schemeClr val="accent1"/>
+          </a:effectRef>
+          <a:fontRef idx="minor">
+            <a:schemeClr val="lt1"/>
+          </a:fontRef>
+        </p:style>
+        <p:txBody>
+          <a:bodyPr rtlCol="0" anchor="ctr"/>
+          <a:lstStyle/>
+          <a:p>
+            <a:pPr algn="ctr"/>
+          </a:p>
+        </p:txBody>
+      </p:sp>
+      <p:sp>
+        <p:nvSpPr>
+          <p:cNvPr id="31" name="TextBox 30"/>
           <p:cNvSpPr txBox="1"/>
           <p:nvPr/>
         </p:nvSpPr>
@@ -16543,7 +18210,7 @@
       </p:sp>
       <p:sp>
         <p:nvSpPr>
-          <p:cNvPr id="30" name="Rounded Rectangle 29"/>
+          <p:cNvPr id="32" name="Rounded Rectangle 31"/>
           <p:cNvSpPr/>
           <p:nvPr/>
         </p:nvSpPr>
@@ -16598,7 +18265,7 @@
       </p:sp>
       <p:sp>
         <p:nvSpPr>
-          <p:cNvPr id="31" name="TextBox 30"/>
+          <p:cNvPr id="33" name="TextBox 32"/>
           <p:cNvSpPr txBox="1"/>
           <p:nvPr/>
         </p:nvSpPr>
@@ -16634,7 +18301,7 @@
       </p:sp>
       <p:sp>
         <p:nvSpPr>
-          <p:cNvPr id="32" name="Rounded Rectangle 31"/>
+          <p:cNvPr id="34" name="Rounded Rectangle 33"/>
           <p:cNvSpPr/>
           <p:nvPr/>
         </p:nvSpPr>
@@ -16679,7 +18346,7 @@
       </p:sp>
       <p:sp>
         <p:nvSpPr>
-          <p:cNvPr id="33" name="Rounded Rectangle 32"/>
+          <p:cNvPr id="35" name="Rounded Rectangle 34"/>
           <p:cNvSpPr/>
           <p:nvPr/>
         </p:nvSpPr>
@@ -16722,7 +18389,50 @@
       </p:sp>
       <p:sp>
         <p:nvSpPr>
-          <p:cNvPr id="34" name="TextBox 33"/>
+          <p:cNvPr id="36" name="Rectangle 35"/>
+          <p:cNvSpPr/>
+          <p:nvPr/>
+        </p:nvSpPr>
+        <p:spPr>
+          <a:xfrm>
+            <a:off x="11201400" y="3044952"/>
+            <a:ext cx="137160" cy="18288"/>
+          </a:xfrm>
+          <a:prstGeom prst="rect">
+            <a:avLst/>
+          </a:prstGeom>
+          <a:solidFill>
+            <a:srgbClr val="818CF8"/>
+          </a:solidFill>
+          <a:ln>
+            <a:noFill/>
+          </a:ln>
+        </p:spPr>
+        <p:style>
+          <a:lnRef idx="1">
+            <a:schemeClr val="accent1"/>
+          </a:lnRef>
+          <a:fillRef idx="3">
+            <a:schemeClr val="accent1"/>
+          </a:fillRef>
+          <a:effectRef idx="2">
+            <a:schemeClr val="accent1"/>
+          </a:effectRef>
+          <a:fontRef idx="minor">
+            <a:schemeClr val="lt1"/>
+          </a:fontRef>
+        </p:style>
+        <p:txBody>
+          <a:bodyPr rtlCol="0" anchor="ctr"/>
+          <a:lstStyle/>
+          <a:p>
+            <a:pPr algn="ctr"/>
+          </a:p>
+        </p:txBody>
+      </p:sp>
+      <p:sp>
+        <p:nvSpPr>
+          <p:cNvPr id="37" name="TextBox 36"/>
           <p:cNvSpPr txBox="1"/>
           <p:nvPr/>
         </p:nvSpPr>
@@ -16758,7 +18468,7 @@
       </p:sp>
       <p:sp>
         <p:nvSpPr>
-          <p:cNvPr id="35" name="Rounded Rectangle 34"/>
+          <p:cNvPr id="38" name="Rounded Rectangle 37"/>
           <p:cNvSpPr/>
           <p:nvPr/>
         </p:nvSpPr>
@@ -16813,7 +18523,7 @@
       </p:sp>
       <p:sp>
         <p:nvSpPr>
-          <p:cNvPr id="36" name="TextBox 35"/>
+          <p:cNvPr id="39" name="TextBox 38"/>
           <p:cNvSpPr txBox="1"/>
           <p:nvPr/>
         </p:nvSpPr>
@@ -16849,7 +18559,7 @@
       </p:sp>
       <p:sp>
         <p:nvSpPr>
-          <p:cNvPr id="37" name="Rounded Rectangle 36"/>
+          <p:cNvPr id="40" name="Rounded Rectangle 39"/>
           <p:cNvSpPr/>
           <p:nvPr/>
         </p:nvSpPr>
@@ -16894,7 +18604,7 @@
       </p:sp>
       <p:sp>
         <p:nvSpPr>
-          <p:cNvPr id="38" name="Rounded Rectangle 37"/>
+          <p:cNvPr id="41" name="Rounded Rectangle 40"/>
           <p:cNvSpPr/>
           <p:nvPr/>
         </p:nvSpPr>
@@ -16937,7 +18647,50 @@
       </p:sp>
       <p:sp>
         <p:nvSpPr>
-          <p:cNvPr id="39" name="TextBox 38"/>
+          <p:cNvPr id="42" name="Rectangle 41"/>
+          <p:cNvSpPr/>
+          <p:nvPr/>
+        </p:nvSpPr>
+        <p:spPr>
+          <a:xfrm>
+            <a:off x="11201400" y="4553712"/>
+            <a:ext cx="137160" cy="18288"/>
+          </a:xfrm>
+          <a:prstGeom prst="rect">
+            <a:avLst/>
+          </a:prstGeom>
+          <a:solidFill>
+            <a:srgbClr val="34D399"/>
+          </a:solidFill>
+          <a:ln>
+            <a:noFill/>
+          </a:ln>
+        </p:spPr>
+        <p:style>
+          <a:lnRef idx="1">
+            <a:schemeClr val="accent1"/>
+          </a:lnRef>
+          <a:fillRef idx="3">
+            <a:schemeClr val="accent1"/>
+          </a:fillRef>
+          <a:effectRef idx="2">
+            <a:schemeClr val="accent1"/>
+          </a:effectRef>
+          <a:fontRef idx="minor">
+            <a:schemeClr val="lt1"/>
+          </a:fontRef>
+        </p:style>
+        <p:txBody>
+          <a:bodyPr rtlCol="0" anchor="ctr"/>
+          <a:lstStyle/>
+          <a:p>
+            <a:pPr algn="ctr"/>
+          </a:p>
+        </p:txBody>
+      </p:sp>
+      <p:sp>
+        <p:nvSpPr>
+          <p:cNvPr id="43" name="TextBox 42"/>
           <p:cNvSpPr txBox="1"/>
           <p:nvPr/>
         </p:nvSpPr>
@@ -16973,7 +18726,7 @@
       </p:sp>
       <p:sp>
         <p:nvSpPr>
-          <p:cNvPr id="40" name="Rounded Rectangle 39"/>
+          <p:cNvPr id="44" name="Rounded Rectangle 43"/>
           <p:cNvSpPr/>
           <p:nvPr/>
         </p:nvSpPr>
@@ -17028,7 +18781,7 @@
       </p:sp>
       <p:sp>
         <p:nvSpPr>
-          <p:cNvPr id="41" name="TextBox 40"/>
+          <p:cNvPr id="45" name="TextBox 44"/>
           <p:cNvSpPr txBox="1"/>
           <p:nvPr/>
         </p:nvSpPr>
@@ -17067,6 +18820,9 @@
   <p:clrMapOvr>
     <a:masterClrMapping/>
   </p:clrMapOvr>
+  <p:transition xmlns:p14="http://schemas.microsoft.com/office/powerpoint/2010/main" spd="med" dur="1500">
+    <p14:morph option="byObject"/>
+  </p:transition>
 </p:sld>
 </file>
 
@@ -17438,7 +19194,50 @@
       </p:sp>
       <p:sp>
         <p:nvSpPr>
-          <p:cNvPr id="10" name="TextBox 9"/>
+          <p:cNvPr id="10" name="Rectangle 9"/>
+          <p:cNvSpPr/>
+          <p:nvPr/>
+        </p:nvSpPr>
+        <p:spPr>
+          <a:xfrm>
+            <a:off x="7955279" y="1536192"/>
+            <a:ext cx="137160" cy="18288"/>
+          </a:xfrm>
+          <a:prstGeom prst="rect">
+            <a:avLst/>
+          </a:prstGeom>
+          <a:solidFill>
+            <a:srgbClr val="38BDF8"/>
+          </a:solidFill>
+          <a:ln>
+            <a:noFill/>
+          </a:ln>
+        </p:spPr>
+        <p:style>
+          <a:lnRef idx="1">
+            <a:schemeClr val="accent1"/>
+          </a:lnRef>
+          <a:fillRef idx="3">
+            <a:schemeClr val="accent1"/>
+          </a:fillRef>
+          <a:effectRef idx="2">
+            <a:schemeClr val="accent1"/>
+          </a:effectRef>
+          <a:fontRef idx="minor">
+            <a:schemeClr val="lt1"/>
+          </a:fontRef>
+        </p:style>
+        <p:txBody>
+          <a:bodyPr rtlCol="0" anchor="ctr"/>
+          <a:lstStyle/>
+          <a:p>
+            <a:pPr algn="ctr"/>
+          </a:p>
+        </p:txBody>
+      </p:sp>
+      <p:sp>
+        <p:nvSpPr>
+          <p:cNvPr id="11" name="TextBox 10"/>
           <p:cNvSpPr txBox="1"/>
           <p:nvPr/>
         </p:nvSpPr>
@@ -17474,7 +19273,7 @@
       </p:sp>
       <p:sp>
         <p:nvSpPr>
-          <p:cNvPr id="11" name="TextBox 10"/>
+          <p:cNvPr id="12" name="TextBox 11"/>
           <p:cNvSpPr txBox="1"/>
           <p:nvPr/>
         </p:nvSpPr>
@@ -17510,7 +19309,7 @@
       </p:sp>
       <p:sp>
         <p:nvSpPr>
-          <p:cNvPr id="12" name="Rounded Rectangle 11"/>
+          <p:cNvPr id="13" name="Rounded Rectangle 12"/>
           <p:cNvSpPr/>
           <p:nvPr/>
         </p:nvSpPr>
@@ -17555,7 +19354,7 @@
       </p:sp>
       <p:sp>
         <p:nvSpPr>
-          <p:cNvPr id="13" name="Rounded Rectangle 12"/>
+          <p:cNvPr id="14" name="Rounded Rectangle 13"/>
           <p:cNvSpPr/>
           <p:nvPr/>
         </p:nvSpPr>
@@ -17598,7 +19397,50 @@
       </p:sp>
       <p:sp>
         <p:nvSpPr>
-          <p:cNvPr id="14" name="TextBox 13"/>
+          <p:cNvPr id="15" name="Rectangle 14"/>
+          <p:cNvSpPr/>
+          <p:nvPr/>
+        </p:nvSpPr>
+        <p:spPr>
+          <a:xfrm>
+            <a:off x="11201399" y="1536192"/>
+            <a:ext cx="137160" cy="18288"/>
+          </a:xfrm>
+          <a:prstGeom prst="rect">
+            <a:avLst/>
+          </a:prstGeom>
+          <a:solidFill>
+            <a:srgbClr val="F59E0B"/>
+          </a:solidFill>
+          <a:ln>
+            <a:noFill/>
+          </a:ln>
+        </p:spPr>
+        <p:style>
+          <a:lnRef idx="1">
+            <a:schemeClr val="accent1"/>
+          </a:lnRef>
+          <a:fillRef idx="3">
+            <a:schemeClr val="accent1"/>
+          </a:fillRef>
+          <a:effectRef idx="2">
+            <a:schemeClr val="accent1"/>
+          </a:effectRef>
+          <a:fontRef idx="minor">
+            <a:schemeClr val="lt1"/>
+          </a:fontRef>
+        </p:style>
+        <p:txBody>
+          <a:bodyPr rtlCol="0" anchor="ctr"/>
+          <a:lstStyle/>
+          <a:p>
+            <a:pPr algn="ctr"/>
+          </a:p>
+        </p:txBody>
+      </p:sp>
+      <p:sp>
+        <p:nvSpPr>
+          <p:cNvPr id="16" name="TextBox 15"/>
           <p:cNvSpPr txBox="1"/>
           <p:nvPr/>
         </p:nvSpPr>
@@ -17634,7 +19476,7 @@
       </p:sp>
       <p:sp>
         <p:nvSpPr>
-          <p:cNvPr id="15" name="TextBox 14"/>
+          <p:cNvPr id="17" name="TextBox 16"/>
           <p:cNvSpPr txBox="1"/>
           <p:nvPr/>
         </p:nvSpPr>
@@ -17670,7 +19512,7 @@
       </p:sp>
       <p:sp>
         <p:nvSpPr>
-          <p:cNvPr id="16" name="Rounded Rectangle 15"/>
+          <p:cNvPr id="18" name="Rounded Rectangle 17"/>
           <p:cNvSpPr/>
           <p:nvPr/>
         </p:nvSpPr>
@@ -17715,7 +19557,7 @@
       </p:sp>
       <p:sp>
         <p:nvSpPr>
-          <p:cNvPr id="17" name="Rounded Rectangle 16"/>
+          <p:cNvPr id="19" name="Rounded Rectangle 18"/>
           <p:cNvSpPr/>
           <p:nvPr/>
         </p:nvSpPr>
@@ -17758,7 +19600,50 @@
       </p:sp>
       <p:sp>
         <p:nvSpPr>
-          <p:cNvPr id="18" name="TextBox 17"/>
+          <p:cNvPr id="20" name="Rectangle 19"/>
+          <p:cNvSpPr/>
+          <p:nvPr/>
+        </p:nvSpPr>
+        <p:spPr>
+          <a:xfrm>
+            <a:off x="11201400" y="3319272"/>
+            <a:ext cx="137160" cy="18288"/>
+          </a:xfrm>
+          <a:prstGeom prst="rect">
+            <a:avLst/>
+          </a:prstGeom>
+          <a:solidFill>
+            <a:srgbClr val="34D399"/>
+          </a:solidFill>
+          <a:ln>
+            <a:noFill/>
+          </a:ln>
+        </p:spPr>
+        <p:style>
+          <a:lnRef idx="1">
+            <a:schemeClr val="accent1"/>
+          </a:lnRef>
+          <a:fillRef idx="3">
+            <a:schemeClr val="accent1"/>
+          </a:fillRef>
+          <a:effectRef idx="2">
+            <a:schemeClr val="accent1"/>
+          </a:effectRef>
+          <a:fontRef idx="minor">
+            <a:schemeClr val="lt1"/>
+          </a:fontRef>
+        </p:style>
+        <p:txBody>
+          <a:bodyPr rtlCol="0" anchor="ctr"/>
+          <a:lstStyle/>
+          <a:p>
+            <a:pPr algn="ctr"/>
+          </a:p>
+        </p:txBody>
+      </p:sp>
+      <p:sp>
+        <p:nvSpPr>
+          <p:cNvPr id="21" name="TextBox 20"/>
           <p:cNvSpPr txBox="1"/>
           <p:nvPr/>
         </p:nvSpPr>
@@ -17794,7 +19679,7 @@
       </p:sp>
       <p:sp>
         <p:nvSpPr>
-          <p:cNvPr id="19" name="TextBox 18"/>
+          <p:cNvPr id="22" name="TextBox 21"/>
           <p:cNvSpPr txBox="1"/>
           <p:nvPr/>
         </p:nvSpPr>
@@ -17830,7 +19715,7 @@
       </p:sp>
       <p:sp>
         <p:nvSpPr>
-          <p:cNvPr id="20" name="TextBox 19"/>
+          <p:cNvPr id="23" name="TextBox 22"/>
           <p:cNvSpPr txBox="1"/>
           <p:nvPr/>
         </p:nvSpPr>
@@ -17866,7 +19751,7 @@
       </p:sp>
       <p:sp>
         <p:nvSpPr>
-          <p:cNvPr id="21" name="Oval 20"/>
+          <p:cNvPr id="24" name="Oval 23"/>
           <p:cNvSpPr/>
           <p:nvPr/>
         </p:nvSpPr>
@@ -17911,7 +19796,7 @@
       </p:sp>
       <p:sp>
         <p:nvSpPr>
-          <p:cNvPr id="22" name="TextBox 21"/>
+          <p:cNvPr id="25" name="TextBox 24"/>
           <p:cNvSpPr txBox="1"/>
           <p:nvPr/>
         </p:nvSpPr>
@@ -17947,7 +19832,7 @@
       </p:sp>
       <p:sp>
         <p:nvSpPr>
-          <p:cNvPr id="23" name="TextBox 22"/>
+          <p:cNvPr id="26" name="TextBox 25"/>
           <p:cNvSpPr txBox="1"/>
           <p:nvPr/>
         </p:nvSpPr>
@@ -17983,7 +19868,7 @@
       </p:sp>
       <p:sp>
         <p:nvSpPr>
-          <p:cNvPr id="24" name="Oval 23"/>
+          <p:cNvPr id="27" name="Oval 26"/>
           <p:cNvSpPr/>
           <p:nvPr/>
         </p:nvSpPr>
@@ -18028,7 +19913,7 @@
       </p:sp>
       <p:sp>
         <p:nvSpPr>
-          <p:cNvPr id="25" name="TextBox 24"/>
+          <p:cNvPr id="28" name="TextBox 27"/>
           <p:cNvSpPr txBox="1"/>
           <p:nvPr/>
         </p:nvSpPr>
@@ -18064,7 +19949,7 @@
       </p:sp>
       <p:sp>
         <p:nvSpPr>
-          <p:cNvPr id="26" name="TextBox 25"/>
+          <p:cNvPr id="29" name="TextBox 28"/>
           <p:cNvSpPr txBox="1"/>
           <p:nvPr/>
         </p:nvSpPr>
@@ -18100,7 +19985,7 @@
       </p:sp>
       <p:sp>
         <p:nvSpPr>
-          <p:cNvPr id="27" name="Oval 26"/>
+          <p:cNvPr id="30" name="Oval 29"/>
           <p:cNvSpPr/>
           <p:nvPr/>
         </p:nvSpPr>
@@ -18145,7 +20030,7 @@
       </p:sp>
       <p:sp>
         <p:nvSpPr>
-          <p:cNvPr id="28" name="TextBox 27"/>
+          <p:cNvPr id="31" name="TextBox 30"/>
           <p:cNvSpPr txBox="1"/>
           <p:nvPr/>
         </p:nvSpPr>
@@ -18181,7 +20066,7 @@
       </p:sp>
       <p:sp>
         <p:nvSpPr>
-          <p:cNvPr id="29" name="TextBox 28"/>
+          <p:cNvPr id="32" name="TextBox 31"/>
           <p:cNvSpPr txBox="1"/>
           <p:nvPr/>
         </p:nvSpPr>
@@ -18217,7 +20102,7 @@
       </p:sp>
       <p:sp>
         <p:nvSpPr>
-          <p:cNvPr id="30" name="Oval 29"/>
+          <p:cNvPr id="33" name="Oval 32"/>
           <p:cNvSpPr/>
           <p:nvPr/>
         </p:nvSpPr>
@@ -18262,7 +20147,7 @@
       </p:sp>
       <p:sp>
         <p:nvSpPr>
-          <p:cNvPr id="31" name="TextBox 30"/>
+          <p:cNvPr id="34" name="TextBox 33"/>
           <p:cNvSpPr txBox="1"/>
           <p:nvPr/>
         </p:nvSpPr>
@@ -18298,7 +20183,7 @@
       </p:sp>
       <p:sp>
         <p:nvSpPr>
-          <p:cNvPr id="32" name="TextBox 31"/>
+          <p:cNvPr id="35" name="TextBox 34"/>
           <p:cNvSpPr txBox="1"/>
           <p:nvPr/>
         </p:nvSpPr>
@@ -18334,7 +20219,7 @@
       </p:sp>
       <p:sp>
         <p:nvSpPr>
-          <p:cNvPr id="33" name="Oval 32"/>
+          <p:cNvPr id="36" name="Oval 35"/>
           <p:cNvSpPr/>
           <p:nvPr/>
         </p:nvSpPr>
@@ -18379,7 +20264,7 @@
       </p:sp>
       <p:sp>
         <p:nvSpPr>
-          <p:cNvPr id="34" name="TextBox 33"/>
+          <p:cNvPr id="37" name="TextBox 36"/>
           <p:cNvSpPr txBox="1"/>
           <p:nvPr/>
         </p:nvSpPr>
@@ -18415,7 +20300,7 @@
       </p:sp>
       <p:sp>
         <p:nvSpPr>
-          <p:cNvPr id="35" name="TextBox 34"/>
+          <p:cNvPr id="38" name="TextBox 37"/>
           <p:cNvSpPr txBox="1"/>
           <p:nvPr/>
         </p:nvSpPr>
@@ -18454,6 +20339,9 @@
   <p:clrMapOvr>
     <a:masterClrMapping/>
   </p:clrMapOvr>
+  <p:transition xmlns:p14="http://schemas.microsoft.com/office/powerpoint/2010/main" spd="med" dur="1500">
+    <p14:morph option="byObject"/>
+  </p:transition>
 </p:sld>
 </file>
 
@@ -18801,7 +20689,50 @@
       </p:sp>
       <p:sp>
         <p:nvSpPr>
-          <p:cNvPr id="9" name="TextBox 8"/>
+          <p:cNvPr id="9" name="Rectangle 8"/>
+          <p:cNvSpPr/>
+          <p:nvPr/>
+        </p:nvSpPr>
+        <p:spPr>
+          <a:xfrm>
+            <a:off x="5715000" y="1536192"/>
+            <a:ext cx="137160" cy="18288"/>
+          </a:xfrm>
+          <a:prstGeom prst="rect">
+            <a:avLst/>
+          </a:prstGeom>
+          <a:solidFill>
+            <a:srgbClr val="38BDF8"/>
+          </a:solidFill>
+          <a:ln>
+            <a:noFill/>
+          </a:ln>
+        </p:spPr>
+        <p:style>
+          <a:lnRef idx="1">
+            <a:schemeClr val="accent1"/>
+          </a:lnRef>
+          <a:fillRef idx="3">
+            <a:schemeClr val="accent1"/>
+          </a:fillRef>
+          <a:effectRef idx="2">
+            <a:schemeClr val="accent1"/>
+          </a:effectRef>
+          <a:fontRef idx="minor">
+            <a:schemeClr val="lt1"/>
+          </a:fontRef>
+        </p:style>
+        <p:txBody>
+          <a:bodyPr rtlCol="0" anchor="ctr"/>
+          <a:lstStyle/>
+          <a:p>
+            <a:pPr algn="ctr"/>
+          </a:p>
+        </p:txBody>
+      </p:sp>
+      <p:sp>
+        <p:nvSpPr>
+          <p:cNvPr id="10" name="TextBox 9"/>
           <p:cNvSpPr txBox="1"/>
           <p:nvPr/>
         </p:nvSpPr>
@@ -18837,7 +20768,7 @@
       </p:sp>
       <p:sp>
         <p:nvSpPr>
-          <p:cNvPr id="10" name="TextBox 9"/>
+          <p:cNvPr id="11" name="TextBox 10"/>
           <p:cNvSpPr txBox="1"/>
           <p:nvPr/>
         </p:nvSpPr>
@@ -18925,7 +20856,7 @@
       </p:sp>
       <p:sp>
         <p:nvSpPr>
-          <p:cNvPr id="11" name="Rounded Rectangle 10"/>
+          <p:cNvPr id="12" name="Rounded Rectangle 11"/>
           <p:cNvSpPr/>
           <p:nvPr/>
         </p:nvSpPr>
@@ -18970,7 +20901,7 @@
       </p:sp>
       <p:sp>
         <p:nvSpPr>
-          <p:cNvPr id="12" name="Rounded Rectangle 11"/>
+          <p:cNvPr id="13" name="Rounded Rectangle 12"/>
           <p:cNvSpPr/>
           <p:nvPr/>
         </p:nvSpPr>
@@ -19013,7 +20944,50 @@
       </p:sp>
       <p:sp>
         <p:nvSpPr>
-          <p:cNvPr id="13" name="TextBox 12"/>
+          <p:cNvPr id="14" name="Rectangle 13"/>
+          <p:cNvSpPr/>
+          <p:nvPr/>
+        </p:nvSpPr>
+        <p:spPr>
+          <a:xfrm>
+            <a:off x="11201400" y="1536192"/>
+            <a:ext cx="137160" cy="18288"/>
+          </a:xfrm>
+          <a:prstGeom prst="rect">
+            <a:avLst/>
+          </a:prstGeom>
+          <a:solidFill>
+            <a:srgbClr val="818CF8"/>
+          </a:solidFill>
+          <a:ln>
+            <a:noFill/>
+          </a:ln>
+        </p:spPr>
+        <p:style>
+          <a:lnRef idx="1">
+            <a:schemeClr val="accent1"/>
+          </a:lnRef>
+          <a:fillRef idx="3">
+            <a:schemeClr val="accent1"/>
+          </a:fillRef>
+          <a:effectRef idx="2">
+            <a:schemeClr val="accent1"/>
+          </a:effectRef>
+          <a:fontRef idx="minor">
+            <a:schemeClr val="lt1"/>
+          </a:fontRef>
+        </p:style>
+        <p:txBody>
+          <a:bodyPr rtlCol="0" anchor="ctr"/>
+          <a:lstStyle/>
+          <a:p>
+            <a:pPr algn="ctr"/>
+          </a:p>
+        </p:txBody>
+      </p:sp>
+      <p:sp>
+        <p:nvSpPr>
+          <p:cNvPr id="15" name="TextBox 14"/>
           <p:cNvSpPr txBox="1"/>
           <p:nvPr/>
         </p:nvSpPr>
@@ -19049,7 +21023,7 @@
       </p:sp>
       <p:sp>
         <p:nvSpPr>
-          <p:cNvPr id="14" name="TextBox 13"/>
+          <p:cNvPr id="16" name="TextBox 15"/>
           <p:cNvSpPr txBox="1"/>
           <p:nvPr/>
         </p:nvSpPr>
@@ -19121,7 +21095,7 @@
       </p:sp>
       <p:sp>
         <p:nvSpPr>
-          <p:cNvPr id="15" name="Rounded Rectangle 14"/>
+          <p:cNvPr id="17" name="Rounded Rectangle 16"/>
           <p:cNvSpPr/>
           <p:nvPr/>
         </p:nvSpPr>
@@ -19166,7 +21140,7 @@
       </p:sp>
       <p:sp>
         <p:nvSpPr>
-          <p:cNvPr id="16" name="Rounded Rectangle 15"/>
+          <p:cNvPr id="18" name="Rounded Rectangle 17"/>
           <p:cNvSpPr/>
           <p:nvPr/>
         </p:nvSpPr>
@@ -19209,7 +21183,50 @@
       </p:sp>
       <p:sp>
         <p:nvSpPr>
-          <p:cNvPr id="17" name="TextBox 16"/>
+          <p:cNvPr id="19" name="Rectangle 18"/>
+          <p:cNvSpPr/>
+          <p:nvPr/>
+        </p:nvSpPr>
+        <p:spPr>
+          <a:xfrm>
+            <a:off x="5715000" y="4462272"/>
+            <a:ext cx="137160" cy="18288"/>
+          </a:xfrm>
+          <a:prstGeom prst="rect">
+            <a:avLst/>
+          </a:prstGeom>
+          <a:solidFill>
+            <a:srgbClr val="38BDF8"/>
+          </a:solidFill>
+          <a:ln>
+            <a:noFill/>
+          </a:ln>
+        </p:spPr>
+        <p:style>
+          <a:lnRef idx="1">
+            <a:schemeClr val="accent1"/>
+          </a:lnRef>
+          <a:fillRef idx="3">
+            <a:schemeClr val="accent1"/>
+          </a:fillRef>
+          <a:effectRef idx="2">
+            <a:schemeClr val="accent1"/>
+          </a:effectRef>
+          <a:fontRef idx="minor">
+            <a:schemeClr val="lt1"/>
+          </a:fontRef>
+        </p:style>
+        <p:txBody>
+          <a:bodyPr rtlCol="0" anchor="ctr"/>
+          <a:lstStyle/>
+          <a:p>
+            <a:pPr algn="ctr"/>
+          </a:p>
+        </p:txBody>
+      </p:sp>
+      <p:sp>
+        <p:nvSpPr>
+          <p:cNvPr id="20" name="TextBox 19"/>
           <p:cNvSpPr txBox="1"/>
           <p:nvPr/>
         </p:nvSpPr>
@@ -19245,7 +21262,7 @@
       </p:sp>
       <p:sp>
         <p:nvSpPr>
-          <p:cNvPr id="18" name="TextBox 17"/>
+          <p:cNvPr id="21" name="TextBox 20"/>
           <p:cNvSpPr txBox="1"/>
           <p:nvPr/>
         </p:nvSpPr>
@@ -19285,7 +21302,7 @@
       </p:sp>
       <p:sp>
         <p:nvSpPr>
-          <p:cNvPr id="19" name="Rounded Rectangle 18"/>
+          <p:cNvPr id="22" name="Rounded Rectangle 21"/>
           <p:cNvSpPr/>
           <p:nvPr/>
         </p:nvSpPr>
@@ -19330,7 +21347,7 @@
       </p:sp>
       <p:sp>
         <p:nvSpPr>
-          <p:cNvPr id="20" name="Rounded Rectangle 19"/>
+          <p:cNvPr id="23" name="Rounded Rectangle 22"/>
           <p:cNvSpPr/>
           <p:nvPr/>
         </p:nvSpPr>
@@ -19373,7 +21390,50 @@
       </p:sp>
       <p:sp>
         <p:nvSpPr>
-          <p:cNvPr id="21" name="TextBox 20"/>
+          <p:cNvPr id="24" name="Rectangle 23"/>
+          <p:cNvSpPr/>
+          <p:nvPr/>
+        </p:nvSpPr>
+        <p:spPr>
+          <a:xfrm>
+            <a:off x="11201400" y="4462272"/>
+            <a:ext cx="137160" cy="18288"/>
+          </a:xfrm>
+          <a:prstGeom prst="rect">
+            <a:avLst/>
+          </a:prstGeom>
+          <a:solidFill>
+            <a:srgbClr val="F43F5E"/>
+          </a:solidFill>
+          <a:ln>
+            <a:noFill/>
+          </a:ln>
+        </p:spPr>
+        <p:style>
+          <a:lnRef idx="1">
+            <a:schemeClr val="accent1"/>
+          </a:lnRef>
+          <a:fillRef idx="3">
+            <a:schemeClr val="accent1"/>
+          </a:fillRef>
+          <a:effectRef idx="2">
+            <a:schemeClr val="accent1"/>
+          </a:effectRef>
+          <a:fontRef idx="minor">
+            <a:schemeClr val="lt1"/>
+          </a:fontRef>
+        </p:style>
+        <p:txBody>
+          <a:bodyPr rtlCol="0" anchor="ctr"/>
+          <a:lstStyle/>
+          <a:p>
+            <a:pPr algn="ctr"/>
+          </a:p>
+        </p:txBody>
+      </p:sp>
+      <p:sp>
+        <p:nvSpPr>
+          <p:cNvPr id="25" name="TextBox 24"/>
           <p:cNvSpPr txBox="1"/>
           <p:nvPr/>
         </p:nvSpPr>
@@ -19409,7 +21469,7 @@
       </p:sp>
       <p:sp>
         <p:nvSpPr>
-          <p:cNvPr id="22" name="TextBox 21"/>
+          <p:cNvPr id="26" name="TextBox 25"/>
           <p:cNvSpPr txBox="1"/>
           <p:nvPr/>
         </p:nvSpPr>
@@ -19452,6 +21512,9 @@
   <p:clrMapOvr>
     <a:masterClrMapping/>
   </p:clrMapOvr>
+  <p:transition xmlns:p14="http://schemas.microsoft.com/office/powerpoint/2010/main" spd="med" dur="1500">
+    <p14:morph option="byObject"/>
+  </p:transition>
 </p:sld>
 </file>
 
@@ -19799,7 +21862,50 @@
       </p:sp>
       <p:sp>
         <p:nvSpPr>
-          <p:cNvPr id="9" name="TextBox 8"/>
+          <p:cNvPr id="9" name="Rectangle 8"/>
+          <p:cNvSpPr/>
+          <p:nvPr/>
+        </p:nvSpPr>
+        <p:spPr>
+          <a:xfrm>
+            <a:off x="5715000" y="1536192"/>
+            <a:ext cx="137160" cy="18288"/>
+          </a:xfrm>
+          <a:prstGeom prst="rect">
+            <a:avLst/>
+          </a:prstGeom>
+          <a:solidFill>
+            <a:srgbClr val="F43F5E"/>
+          </a:solidFill>
+          <a:ln>
+            <a:noFill/>
+          </a:ln>
+        </p:spPr>
+        <p:style>
+          <a:lnRef idx="1">
+            <a:schemeClr val="accent1"/>
+          </a:lnRef>
+          <a:fillRef idx="3">
+            <a:schemeClr val="accent1"/>
+          </a:fillRef>
+          <a:effectRef idx="2">
+            <a:schemeClr val="accent1"/>
+          </a:effectRef>
+          <a:fontRef idx="minor">
+            <a:schemeClr val="lt1"/>
+          </a:fontRef>
+        </p:style>
+        <p:txBody>
+          <a:bodyPr rtlCol="0" anchor="ctr"/>
+          <a:lstStyle/>
+          <a:p>
+            <a:pPr algn="ctr"/>
+          </a:p>
+        </p:txBody>
+      </p:sp>
+      <p:sp>
+        <p:nvSpPr>
+          <p:cNvPr id="10" name="TextBox 9"/>
           <p:cNvSpPr txBox="1"/>
           <p:nvPr/>
         </p:nvSpPr>
@@ -19835,7 +21941,7 @@
       </p:sp>
       <p:sp>
         <p:nvSpPr>
-          <p:cNvPr id="10" name="TextBox 9"/>
+          <p:cNvPr id="11" name="TextBox 10"/>
           <p:cNvSpPr txBox="1"/>
           <p:nvPr/>
         </p:nvSpPr>
@@ -19907,7 +22013,7 @@
       </p:sp>
       <p:sp>
         <p:nvSpPr>
-          <p:cNvPr id="11" name="TextBox 10"/>
+          <p:cNvPr id="12" name="TextBox 11"/>
           <p:cNvSpPr txBox="1"/>
           <p:nvPr/>
         </p:nvSpPr>
@@ -19943,7 +22049,7 @@
       </p:sp>
       <p:sp>
         <p:nvSpPr>
-          <p:cNvPr id="12" name="Oval 11"/>
+          <p:cNvPr id="13" name="Oval 12"/>
           <p:cNvSpPr/>
           <p:nvPr/>
         </p:nvSpPr>
@@ -19988,7 +22094,7 @@
       </p:sp>
       <p:sp>
         <p:nvSpPr>
-          <p:cNvPr id="13" name="TextBox 12"/>
+          <p:cNvPr id="14" name="TextBox 13"/>
           <p:cNvSpPr txBox="1"/>
           <p:nvPr/>
         </p:nvSpPr>
@@ -20024,7 +22130,7 @@
       </p:sp>
       <p:sp>
         <p:nvSpPr>
-          <p:cNvPr id="14" name="TextBox 13"/>
+          <p:cNvPr id="15" name="TextBox 14"/>
           <p:cNvSpPr txBox="1"/>
           <p:nvPr/>
         </p:nvSpPr>
@@ -20064,7 +22170,7 @@
       </p:sp>
       <p:sp>
         <p:nvSpPr>
-          <p:cNvPr id="15" name="Oval 14"/>
+          <p:cNvPr id="16" name="Oval 15"/>
           <p:cNvSpPr/>
           <p:nvPr/>
         </p:nvSpPr>
@@ -20109,7 +22215,7 @@
       </p:sp>
       <p:sp>
         <p:nvSpPr>
-          <p:cNvPr id="16" name="TextBox 15"/>
+          <p:cNvPr id="17" name="TextBox 16"/>
           <p:cNvSpPr txBox="1"/>
           <p:nvPr/>
         </p:nvSpPr>
@@ -20145,7 +22251,7 @@
       </p:sp>
       <p:sp>
         <p:nvSpPr>
-          <p:cNvPr id="17" name="TextBox 16"/>
+          <p:cNvPr id="18" name="TextBox 17"/>
           <p:cNvSpPr txBox="1"/>
           <p:nvPr/>
         </p:nvSpPr>
@@ -20185,7 +22291,7 @@
       </p:sp>
       <p:sp>
         <p:nvSpPr>
-          <p:cNvPr id="18" name="Oval 17"/>
+          <p:cNvPr id="19" name="Oval 18"/>
           <p:cNvSpPr/>
           <p:nvPr/>
         </p:nvSpPr>
@@ -20230,7 +22336,7 @@
       </p:sp>
       <p:sp>
         <p:nvSpPr>
-          <p:cNvPr id="19" name="TextBox 18"/>
+          <p:cNvPr id="20" name="TextBox 19"/>
           <p:cNvSpPr txBox="1"/>
           <p:nvPr/>
         </p:nvSpPr>
@@ -20266,7 +22372,7 @@
       </p:sp>
       <p:sp>
         <p:nvSpPr>
-          <p:cNvPr id="20" name="TextBox 19"/>
+          <p:cNvPr id="21" name="TextBox 20"/>
           <p:cNvSpPr txBox="1"/>
           <p:nvPr/>
         </p:nvSpPr>
@@ -20306,7 +22412,7 @@
       </p:sp>
       <p:sp>
         <p:nvSpPr>
-          <p:cNvPr id="21" name="Rounded Rectangle 20"/>
+          <p:cNvPr id="22" name="Rounded Rectangle 21"/>
           <p:cNvSpPr/>
           <p:nvPr/>
         </p:nvSpPr>
@@ -20351,7 +22457,7 @@
       </p:sp>
       <p:sp>
         <p:nvSpPr>
-          <p:cNvPr id="22" name="Rounded Rectangle 21"/>
+          <p:cNvPr id="23" name="Rounded Rectangle 22"/>
           <p:cNvSpPr/>
           <p:nvPr/>
         </p:nvSpPr>
@@ -20394,7 +22500,50 @@
       </p:sp>
       <p:sp>
         <p:nvSpPr>
-          <p:cNvPr id="23" name="TextBox 22"/>
+          <p:cNvPr id="24" name="Rectangle 23"/>
+          <p:cNvSpPr/>
+          <p:nvPr/>
+        </p:nvSpPr>
+        <p:spPr>
+          <a:xfrm>
+            <a:off x="11201400" y="1536192"/>
+            <a:ext cx="137160" cy="18288"/>
+          </a:xfrm>
+          <a:prstGeom prst="rect">
+            <a:avLst/>
+          </a:prstGeom>
+          <a:solidFill>
+            <a:srgbClr val="F43F5E"/>
+          </a:solidFill>
+          <a:ln>
+            <a:noFill/>
+          </a:ln>
+        </p:spPr>
+        <p:style>
+          <a:lnRef idx="1">
+            <a:schemeClr val="accent1"/>
+          </a:lnRef>
+          <a:fillRef idx="3">
+            <a:schemeClr val="accent1"/>
+          </a:fillRef>
+          <a:effectRef idx="2">
+            <a:schemeClr val="accent1"/>
+          </a:effectRef>
+          <a:fontRef idx="minor">
+            <a:schemeClr val="lt1"/>
+          </a:fontRef>
+        </p:style>
+        <p:txBody>
+          <a:bodyPr rtlCol="0" anchor="ctr"/>
+          <a:lstStyle/>
+          <a:p>
+            <a:pPr algn="ctr"/>
+          </a:p>
+        </p:txBody>
+      </p:sp>
+      <p:sp>
+        <p:nvSpPr>
+          <p:cNvPr id="25" name="TextBox 24"/>
           <p:cNvSpPr txBox="1"/>
           <p:nvPr/>
         </p:nvSpPr>
@@ -20430,7 +22579,7 @@
       </p:sp>
       <p:sp>
         <p:nvSpPr>
-          <p:cNvPr id="24" name="Rounded Rectangle 23"/>
+          <p:cNvPr id="26" name="Rounded Rectangle 25"/>
           <p:cNvSpPr/>
           <p:nvPr/>
         </p:nvSpPr>
@@ -20485,7 +22634,7 @@
       </p:sp>
       <p:sp>
         <p:nvSpPr>
-          <p:cNvPr id="25" name="TextBox 24"/>
+          <p:cNvPr id="27" name="TextBox 26"/>
           <p:cNvSpPr txBox="1"/>
           <p:nvPr/>
         </p:nvSpPr>
@@ -20521,7 +22670,7 @@
       </p:sp>
       <p:sp>
         <p:nvSpPr>
-          <p:cNvPr id="26" name="Rounded Rectangle 25"/>
+          <p:cNvPr id="28" name="Rounded Rectangle 27"/>
           <p:cNvSpPr/>
           <p:nvPr/>
         </p:nvSpPr>
@@ -20566,7 +22715,7 @@
       </p:sp>
       <p:sp>
         <p:nvSpPr>
-          <p:cNvPr id="27" name="Rounded Rectangle 26"/>
+          <p:cNvPr id="29" name="Rounded Rectangle 28"/>
           <p:cNvSpPr/>
           <p:nvPr/>
         </p:nvSpPr>
@@ -20609,7 +22758,50 @@
       </p:sp>
       <p:sp>
         <p:nvSpPr>
-          <p:cNvPr id="28" name="TextBox 27"/>
+          <p:cNvPr id="30" name="Rectangle 29"/>
+          <p:cNvSpPr/>
+          <p:nvPr/>
+        </p:nvSpPr>
+        <p:spPr>
+          <a:xfrm>
+            <a:off x="11201400" y="3044952"/>
+            <a:ext cx="137160" cy="18288"/>
+          </a:xfrm>
+          <a:prstGeom prst="rect">
+            <a:avLst/>
+          </a:prstGeom>
+          <a:solidFill>
+            <a:srgbClr val="34D399"/>
+          </a:solidFill>
+          <a:ln>
+            <a:noFill/>
+          </a:ln>
+        </p:spPr>
+        <p:style>
+          <a:lnRef idx="1">
+            <a:schemeClr val="accent1"/>
+          </a:lnRef>
+          <a:fillRef idx="3">
+            <a:schemeClr val="accent1"/>
+          </a:fillRef>
+          <a:effectRef idx="2">
+            <a:schemeClr val="accent1"/>
+          </a:effectRef>
+          <a:fontRef idx="minor">
+            <a:schemeClr val="lt1"/>
+          </a:fontRef>
+        </p:style>
+        <p:txBody>
+          <a:bodyPr rtlCol="0" anchor="ctr"/>
+          <a:lstStyle/>
+          <a:p>
+            <a:pPr algn="ctr"/>
+          </a:p>
+        </p:txBody>
+      </p:sp>
+      <p:sp>
+        <p:nvSpPr>
+          <p:cNvPr id="31" name="TextBox 30"/>
           <p:cNvSpPr txBox="1"/>
           <p:nvPr/>
         </p:nvSpPr>
@@ -20645,7 +22837,7 @@
       </p:sp>
       <p:sp>
         <p:nvSpPr>
-          <p:cNvPr id="29" name="Rounded Rectangle 28"/>
+          <p:cNvPr id="32" name="Rounded Rectangle 31"/>
           <p:cNvSpPr/>
           <p:nvPr/>
         </p:nvSpPr>
@@ -20700,7 +22892,7 @@
       </p:sp>
       <p:sp>
         <p:nvSpPr>
-          <p:cNvPr id="30" name="TextBox 29"/>
+          <p:cNvPr id="33" name="TextBox 32"/>
           <p:cNvSpPr txBox="1"/>
           <p:nvPr/>
         </p:nvSpPr>
@@ -20736,7 +22928,7 @@
       </p:sp>
       <p:sp>
         <p:nvSpPr>
-          <p:cNvPr id="31" name="Rounded Rectangle 30"/>
+          <p:cNvPr id="34" name="Rounded Rectangle 33"/>
           <p:cNvSpPr/>
           <p:nvPr/>
         </p:nvSpPr>
@@ -20781,7 +22973,7 @@
       </p:sp>
       <p:sp>
         <p:nvSpPr>
-          <p:cNvPr id="32" name="Rounded Rectangle 31"/>
+          <p:cNvPr id="35" name="Rounded Rectangle 34"/>
           <p:cNvSpPr/>
           <p:nvPr/>
         </p:nvSpPr>
@@ -20824,7 +23016,50 @@
       </p:sp>
       <p:sp>
         <p:nvSpPr>
-          <p:cNvPr id="33" name="TextBox 32"/>
+          <p:cNvPr id="36" name="Rectangle 35"/>
+          <p:cNvSpPr/>
+          <p:nvPr/>
+        </p:nvSpPr>
+        <p:spPr>
+          <a:xfrm>
+            <a:off x="11201400" y="4553712"/>
+            <a:ext cx="137160" cy="18288"/>
+          </a:xfrm>
+          <a:prstGeom prst="rect">
+            <a:avLst/>
+          </a:prstGeom>
+          <a:solidFill>
+            <a:srgbClr val="38BDF8"/>
+          </a:solidFill>
+          <a:ln>
+            <a:noFill/>
+          </a:ln>
+        </p:spPr>
+        <p:style>
+          <a:lnRef idx="1">
+            <a:schemeClr val="accent1"/>
+          </a:lnRef>
+          <a:fillRef idx="3">
+            <a:schemeClr val="accent1"/>
+          </a:fillRef>
+          <a:effectRef idx="2">
+            <a:schemeClr val="accent1"/>
+          </a:effectRef>
+          <a:fontRef idx="minor">
+            <a:schemeClr val="lt1"/>
+          </a:fontRef>
+        </p:style>
+        <p:txBody>
+          <a:bodyPr rtlCol="0" anchor="ctr"/>
+          <a:lstStyle/>
+          <a:p>
+            <a:pPr algn="ctr"/>
+          </a:p>
+        </p:txBody>
+      </p:sp>
+      <p:sp>
+        <p:nvSpPr>
+          <p:cNvPr id="37" name="TextBox 36"/>
           <p:cNvSpPr txBox="1"/>
           <p:nvPr/>
         </p:nvSpPr>
@@ -20860,7 +23095,7 @@
       </p:sp>
       <p:sp>
         <p:nvSpPr>
-          <p:cNvPr id="34" name="Rounded Rectangle 33"/>
+          <p:cNvPr id="38" name="Rounded Rectangle 37"/>
           <p:cNvSpPr/>
           <p:nvPr/>
         </p:nvSpPr>
@@ -20915,7 +23150,7 @@
       </p:sp>
       <p:sp>
         <p:nvSpPr>
-          <p:cNvPr id="35" name="TextBox 34"/>
+          <p:cNvPr id="39" name="TextBox 38"/>
           <p:cNvSpPr txBox="1"/>
           <p:nvPr/>
         </p:nvSpPr>
@@ -20954,6 +23189,9 @@
   <p:clrMapOvr>
     <a:masterClrMapping/>
   </p:clrMapOvr>
+  <p:transition xmlns:p14="http://schemas.microsoft.com/office/powerpoint/2010/main" spd="med" dur="1500">
+    <p14:morph option="byObject"/>
+  </p:transition>
 </p:sld>
 </file>
 

</xml_diff>

<commit_message>
feat(presentation): upgrade visuals to photorealistic Zero-Gravity Exploded View 3D assets
</commit_message>
<xml_diff>
--- a/Computer_System_Architecture_Cinematic.pptx
+++ b/Computer_System_Architecture_Cinematic.pptx
@@ -5665,8 +5665,8 @@
         </p:blipFill>
         <p:spPr>
           <a:xfrm>
-            <a:off x="6858000" y="731520"/>
-            <a:ext cx="4754880" cy="4754880"/>
+            <a:off x="6583680" y="1188720"/>
+            <a:ext cx="4937760" cy="2755959"/>
           </a:xfrm>
           <a:prstGeom prst="rect">
             <a:avLst/>
@@ -9243,7 +9243,7 @@
         <p:spPr>
           <a:xfrm>
             <a:off x="6400800" y="1371600"/>
-            <a:ext cx="5029200" cy="5029200"/>
+            <a:ext cx="5029200" cy="2806995"/>
           </a:xfrm>
           <a:prstGeom prst="rect">
             <a:avLst/>
@@ -14718,7 +14718,7 @@
         <p:spPr>
           <a:xfrm>
             <a:off x="6400800" y="1371600"/>
-            <a:ext cx="5029200" cy="4733365"/>
+            <a:ext cx="5029200" cy="2806995"/>
           </a:xfrm>
           <a:prstGeom prst="rect">
             <a:avLst/>
@@ -17628,7 +17628,7 @@
         <p:spPr>
           <a:xfrm>
             <a:off x="6400800" y="1371600"/>
-            <a:ext cx="5029200" cy="5029200"/>
+            <a:ext cx="5029200" cy="2806995"/>
           </a:xfrm>
           <a:prstGeom prst="rect">
             <a:avLst/>

</xml_diff>

<commit_message>
feat(presentation): lock team as V. Ram Charan (Act I), Vedhanth (Act II), Lochan (Act III)
</commit_message>
<xml_diff>
--- a/Computer_System_Architecture_Cinematic.pptx
+++ b/Computer_System_Architecture_Cinematic.pptx
@@ -527,7 +527,7 @@
           </a:p>
           <a:p>
             <a:r>
-              <a:t>Good morning everyone. I’ll be explaining the core hardware of a computer system. Together with Vedhanth and Nidhi, we will walk you through how hardware components communicate, how memory hierarchies optimize speed and capacity, and how modern multiprocessing systems scale concurrent execution.</a:t>
+              <a:t>Good morning everyone. I’ll be explaining the core hardware of a computer system. Together with Vedhanth and Lochan, we will walk you through how hardware components communicate, how memory hierarchies optimize speed and capacity, and how modern multiprocessing systems scale concurrent execution.</a:t>
             </a:r>
           </a:p>
           <a:p/>
@@ -641,7 +641,7 @@
           </a:p>
           <a:p>
             <a:r>
-              <a:t>The OS uses techniques such as paging, buffering, disk caching, and prefetching to use this hierarchy efficiently. Now Nidhi will take over to discuss multiprocessing.</a:t>
+              <a:t>The OS uses techniques such as paging, buffering, disk caching, and prefetching to use this hierarchy efficiently. Now Lochan will take over to discuss multiprocessing.</a:t>
             </a:r>
           </a:p>
           <a:p/>
@@ -663,7 +663,7 @@
           </a:p>
           <a:p>
             <a:r>
-              <a:t>I will now pass the presentation to Nidhi, who will explain multiprocessing, modern multicore systems, and OS challenges.</a:t>
+              <a:t>I will now pass the presentation to Lochan, who will explain multiprocessing, modern multicore systems, and OS challenges.</a:t>
             </a:r>
           </a:p>
           <a:p/>
@@ -674,7 +674,7 @@
           </a:p>
           <a:p>
             <a:r>
-              <a:t>Hand over clicker to Nidhi.</a:t>
+              <a:t>Hand over clicker to Lochan.</a:t>
             </a:r>
           </a:p>
         </p:txBody>
@@ -1211,7 +1211,7 @@
           </a:p>
           <a:p>
             <a:r>
-              <a:t>To summarize our complete presentation: Ram Charan walked us through the core hardware and 3-part system bus; Vedhanth explained the storage hierarchy, locality of reference, and OS caching optimizations; and Nidhi covered multiprocessing architectures, SMP vs AMP, multicore, clustering, and OS coordination challenges. On behalf of Ram Charan, Vedhanth, and Nidhi, thank you for your attention. We are now open for questions.</a:t>
+              <a:t>To summarize our complete presentation: Ram Charan walked us through the core hardware and 3-part system bus; Vedhanth explained the storage hierarchy, locality of reference, and OS caching optimizations; and Lochan covered multiprocessing architectures, SMP vs AMP, multicore, clustering, and OS coordination challenges. On behalf of Ram Charan, Vedhanth, and Lochan, thank you for your attention. We are now open for questions.</a:t>
             </a:r>
           </a:p>
           <a:p/>
@@ -5517,7 +5517,7 @@
               </a:defRPr>
             </a:pPr>
             <a:r>
-              <a:t>Nidhi</a:t>
+              <a:t>Lochan</a:t>
             </a:r>
           </a:p>
           <a:p>
@@ -6894,7 +6894,7 @@
               </a:defRPr>
             </a:pPr>
             <a:r>
-              <a:t>PRESENTER: NIDHI</a:t>
+              <a:t>PRESENTER: LOCHAN</a:t>
             </a:r>
           </a:p>
         </p:txBody>
@@ -7704,7 +7704,7 @@
               </a:defRPr>
             </a:pPr>
             <a:r>
-              <a:t>PRESENTER: NIDHI</a:t>
+              <a:t>PRESENTER: LOCHAN</a:t>
             </a:r>
           </a:p>
         </p:txBody>
@@ -8586,7 +8586,7 @@
               </a:defRPr>
             </a:pPr>
             <a:r>
-              <a:t>PRESENTER: NIDHI</a:t>
+              <a:t>PRESENTER: LOCHAN</a:t>
             </a:r>
           </a:p>
         </p:txBody>
@@ -9398,7 +9398,7 @@
               </a:defRPr>
             </a:pPr>
             <a:r>
-              <a:t>PRESENTER: NIDHI</a:t>
+              <a:t>PRESENTER: LOCHAN</a:t>
             </a:r>
           </a:p>
         </p:txBody>
@@ -10520,7 +10520,7 @@
               </a:defRPr>
             </a:pPr>
             <a:r>
-              <a:t>PRESENTER: V. RAM CHARAN · VEDHANTH · NIDHI</a:t>
+              <a:t>PRESENTER: V. RAM CHARAN · VEDHANTH · LOCHAN</a:t>
             </a:r>
           </a:p>
         </p:txBody>
@@ -12234,7 +12234,7 @@
               </a:defRPr>
             </a:pPr>
             <a:r>
-              <a:t>Nidhi</a:t>
+              <a:t>Lochan</a:t>
             </a:r>
           </a:p>
         </p:txBody>

</xml_diff>